<commit_message>
fix: atualizar links publicos apos transferencia do repositorio
</commit_message>
<xml_diff>
--- a/public/materiais/trilum-conecta-coday-2026-apresentacao.pptx
+++ b/public/materiais/trilum-conecta-coday-2026-apresentacao.pptx
@@ -2,18 +2,18 @@
 <file path=ppt/presentation.xml><?xml version="1.0" encoding="utf-8"?>
 <p:presentation xmlns:p="http://schemas.openxmlformats.org/presentationml/2006/main">
   <p:sldMasterIdLst>
-    <p:sldMasterId xmlns:r="http://schemas.openxmlformats.org/officeDocument/2006/relationships" id="2147483648" r:id="R0c28ce25128249be"/>
+    <p:sldMasterId xmlns:r="http://schemas.openxmlformats.org/officeDocument/2006/relationships" id="2147483648" r:id="R45a61087bf5b444d"/>
   </p:sldMasterIdLst>
   <p:notesMasterIdLst>
-    <p:notesMasterId xmlns:r="http://schemas.openxmlformats.org/officeDocument/2006/relationships" r:id="Rda122d2dd7374b86"/>
+    <p:notesMasterId xmlns:r="http://schemas.openxmlformats.org/officeDocument/2006/relationships" r:id="Rb56859975f4c42c3"/>
   </p:notesMasterIdLst>
   <p:sldIdLst>
-    <p:sldId xmlns:r="http://schemas.openxmlformats.org/officeDocument/2006/relationships" id="256" r:id="Re5598344047b42fb"/>
-    <p:sldId xmlns:r="http://schemas.openxmlformats.org/officeDocument/2006/relationships" id="257" r:id="Rffeccbf484b34550"/>
-    <p:sldId xmlns:r="http://schemas.openxmlformats.org/officeDocument/2006/relationships" id="258" r:id="Rfe4321dae465404c"/>
-    <p:sldId xmlns:r="http://schemas.openxmlformats.org/officeDocument/2006/relationships" id="259" r:id="Rf701947241464c6e"/>
-    <p:sldId xmlns:r="http://schemas.openxmlformats.org/officeDocument/2006/relationships" id="260" r:id="Rb4965ff1dfe54701"/>
-    <p:sldId xmlns:r="http://schemas.openxmlformats.org/officeDocument/2006/relationships" id="261" r:id="Rf26a27f00bbb4f5d"/>
+    <p:sldId xmlns:r="http://schemas.openxmlformats.org/officeDocument/2006/relationships" id="256" r:id="R14a6f48b3a3b420c"/>
+    <p:sldId xmlns:r="http://schemas.openxmlformats.org/officeDocument/2006/relationships" id="257" r:id="Ra86ec7db86974e78"/>
+    <p:sldId xmlns:r="http://schemas.openxmlformats.org/officeDocument/2006/relationships" id="258" r:id="R9d6449cd00294099"/>
+    <p:sldId xmlns:r="http://schemas.openxmlformats.org/officeDocument/2006/relationships" id="259" r:id="R616a253ce6194421"/>
+    <p:sldId xmlns:r="http://schemas.openxmlformats.org/officeDocument/2006/relationships" id="260" r:id="R7227a197fd3e4b7f"/>
+    <p:sldId xmlns:r="http://schemas.openxmlformats.org/officeDocument/2006/relationships" id="261" r:id="Rfc19a1f13167452e"/>
   </p:sldIdLst>
   <p:sldSz cx="12192000" cy="6858000"/>
   <p:notesSz cx="6858000" cy="9144000"/>
@@ -936,7 +936,7 @@
   </p:cSld>
   <p:clrMap bg1="lt1" tx1="dk1" bg2="lt2" tx2="dk2" accent1="accent1" accent2="accent2" accent3="accent3" accent4="accent4" accent5="accent5" accent6="accent6" hlink="hlink" folHlink="folHlink"/>
   <p:sldLayoutIdLst>
-    <p:sldLayoutId xmlns:r="http://schemas.openxmlformats.org/officeDocument/2006/relationships" id="2147483649" r:id="R56a36d97bdcd4e23"/>
+    <p:sldLayoutId xmlns:r="http://schemas.openxmlformats.org/officeDocument/2006/relationships" id="2147483649" r:id="R431a6ea73a204721"/>
   </p:sldLayoutIdLst>
   <p:txStyles>
     <p:titleStyle>
@@ -1487,7 +1487,7 @@
           <p:cNvPr id="1" name="">
             <a:extLst xmlns:a="http://schemas.openxmlformats.org/drawingml/2006/main">
               <a:ext uri="{FF2B5EF4-FFF2-40B4-BE49-F238E27FC236}">
-                <a16:creationId xmlns:a16="http://schemas.microsoft.com/office/drawing/2014/main" id="{0605C6EA-F569-47A8-9859-B12E4C81FCE1}"/>
+                <a16:creationId xmlns:a16="http://schemas.microsoft.com/office/drawing/2014/main" id="{766AF943-EFE9-4AB5-B47A-ABC79F81B369}"/>
               </a:ext>
             </a:extLst>
           </p:cNvPr>
@@ -1530,7 +1530,7 @@
           <p:nvPr/>
         </p:nvPicPr>
         <p:blipFill>
-          <a:blip xmlns:r="http://schemas.openxmlformats.org/officeDocument/2006/relationships" xmlns:a="http://schemas.openxmlformats.org/drawingml/2006/main" r:embed="Rce9d9d61edbd4d6e"/>
+          <a:blip xmlns:r="http://schemas.openxmlformats.org/officeDocument/2006/relationships" xmlns:a="http://schemas.openxmlformats.org/drawingml/2006/main" r:embed="R0c8cc611f6634643"/>
           <a:srcRect xmlns:a="http://schemas.openxmlformats.org/drawingml/2006/main" l="0" t="14300" r="0" b="14300"/>
           <a:stretch xmlns:a="http://schemas.openxmlformats.org/drawingml/2006/main">
             <a:fillRect l="0" t="0" r="0" b="0"/>
@@ -1551,7 +1551,7 @@
           <p:cNvPr id="3" name="">
             <a:extLst xmlns:a="http://schemas.openxmlformats.org/drawingml/2006/main">
               <a:ext uri="{FF2B5EF4-FFF2-40B4-BE49-F238E27FC236}">
-                <a16:creationId xmlns:a16="http://schemas.microsoft.com/office/drawing/2014/main" id="{64B4664F-3C1F-49F0-B50F-FD0B05676BC4}"/>
+                <a16:creationId xmlns:a16="http://schemas.microsoft.com/office/drawing/2014/main" id="{81AB340B-E480-47BB-BE7F-E64FB690B231}"/>
               </a:ext>
             </a:extLst>
           </p:cNvPr>
@@ -1579,7 +1579,7 @@
           <p:cNvPr id="4" name="">
             <a:extLst xmlns:a="http://schemas.openxmlformats.org/drawingml/2006/main">
               <a:ext uri="{FF2B5EF4-FFF2-40B4-BE49-F238E27FC236}">
-                <a16:creationId xmlns:a16="http://schemas.microsoft.com/office/drawing/2014/main" id="{EA9BF5D2-B1EE-4CAD-96BB-CCF9E833E1ED}"/>
+                <a16:creationId xmlns:a16="http://schemas.microsoft.com/office/drawing/2014/main" id="{71C16641-ADA9-465E-ADA6-4BAA90AE660A}"/>
               </a:ext>
             </a:extLst>
           </p:cNvPr>
@@ -1624,7 +1624,7 @@
           <p:nvPr/>
         </p:nvPicPr>
         <p:blipFill>
-          <a:blip xmlns:r="http://schemas.openxmlformats.org/officeDocument/2006/relationships" xmlns:a="http://schemas.openxmlformats.org/drawingml/2006/main" r:embed="R0e7c6f708edd4250"/>
+          <a:blip xmlns:r="http://schemas.openxmlformats.org/officeDocument/2006/relationships" xmlns:a="http://schemas.openxmlformats.org/drawingml/2006/main" r:embed="Rd92c559b70f44c77"/>
           <a:stretch xmlns:a="http://schemas.openxmlformats.org/drawingml/2006/main"/>
         </p:blipFill>
         <p:spPr>
@@ -1644,7 +1644,7 @@
           <p:cNvPr id="6" name="">
             <a:extLst xmlns:a="http://schemas.openxmlformats.org/drawingml/2006/main">
               <a:ext uri="{FF2B5EF4-FFF2-40B4-BE49-F238E27FC236}">
-                <a16:creationId xmlns:a16="http://schemas.microsoft.com/office/drawing/2014/main" id="{5A2CA7C9-9648-4017-975F-52FC2EBEB7C7}"/>
+                <a16:creationId xmlns:a16="http://schemas.microsoft.com/office/drawing/2014/main" id="{F4DA1AED-7A38-4F45-B97D-DE6CBCB287EE}"/>
               </a:ext>
             </a:extLst>
           </p:cNvPr>
@@ -1700,7 +1700,7 @@
           <p:cNvPr id="7" name="">
             <a:extLst xmlns:a="http://schemas.openxmlformats.org/drawingml/2006/main">
               <a:ext uri="{FF2B5EF4-FFF2-40B4-BE49-F238E27FC236}">
-                <a16:creationId xmlns:a16="http://schemas.microsoft.com/office/drawing/2014/main" id="{4F04D2FD-22AE-4B5F-840E-0F9E99134FA5}"/>
+                <a16:creationId xmlns:a16="http://schemas.microsoft.com/office/drawing/2014/main" id="{86F59CC9-8C60-498D-B51B-DD52EEB77775}"/>
               </a:ext>
             </a:extLst>
           </p:cNvPr>
@@ -1756,7 +1756,7 @@
           <p:cNvPr id="8" name="">
             <a:extLst xmlns:a="http://schemas.openxmlformats.org/drawingml/2006/main">
               <a:ext uri="{FF2B5EF4-FFF2-40B4-BE49-F238E27FC236}">
-                <a16:creationId xmlns:a16="http://schemas.microsoft.com/office/drawing/2014/main" id="{94438821-5E24-494A-86D2-EAE46B78CD20}"/>
+                <a16:creationId xmlns:a16="http://schemas.microsoft.com/office/drawing/2014/main" id="{5577AD0A-B0AC-41AD-8891-9B1F0B0D61F6}"/>
               </a:ext>
             </a:extLst>
           </p:cNvPr>
@@ -1835,7 +1835,7 @@
           <p:cNvPr id="9" name="">
             <a:extLst xmlns:a="http://schemas.openxmlformats.org/drawingml/2006/main">
               <a:ext uri="{FF2B5EF4-FFF2-40B4-BE49-F238E27FC236}">
-                <a16:creationId xmlns:a16="http://schemas.microsoft.com/office/drawing/2014/main" id="{1BAD1798-4245-46E1-800E-57E1737DD0C9}"/>
+                <a16:creationId xmlns:a16="http://schemas.microsoft.com/office/drawing/2014/main" id="{DD51C361-43C8-4D8A-BD2C-36EAB3953275}"/>
               </a:ext>
             </a:extLst>
           </p:cNvPr>
@@ -1914,7 +1914,7 @@
           <p:cNvPr id="10" name="">
             <a:extLst xmlns:a="http://schemas.openxmlformats.org/drawingml/2006/main">
               <a:ext uri="{FF2B5EF4-FFF2-40B4-BE49-F238E27FC236}">
-                <a16:creationId xmlns:a16="http://schemas.microsoft.com/office/drawing/2014/main" id="{F7AA9EA4-89F8-488E-9770-D04D1A59F43D}"/>
+                <a16:creationId xmlns:a16="http://schemas.microsoft.com/office/drawing/2014/main" id="{0142AC7E-DFA1-4015-9F0D-E102E0E26643}"/>
               </a:ext>
             </a:extLst>
           </p:cNvPr>
@@ -1955,7 +1955,7 @@
           <p:cNvPr id="11" name="">
             <a:extLst xmlns:a="http://schemas.openxmlformats.org/drawingml/2006/main">
               <a:ext uri="{FF2B5EF4-FFF2-40B4-BE49-F238E27FC236}">
-                <a16:creationId xmlns:a16="http://schemas.microsoft.com/office/drawing/2014/main" id="{0B7E59F0-1F74-470F-9F13-278136B27413}"/>
+                <a16:creationId xmlns:a16="http://schemas.microsoft.com/office/drawing/2014/main" id="{B63BBD78-8175-4227-8315-A20C508F025D}"/>
               </a:ext>
             </a:extLst>
           </p:cNvPr>
@@ -2011,7 +2011,7 @@
           <p:cNvPr id="12" name="">
             <a:extLst xmlns:a="http://schemas.openxmlformats.org/drawingml/2006/main">
               <a:ext uri="{FF2B5EF4-FFF2-40B4-BE49-F238E27FC236}">
-                <a16:creationId xmlns:a16="http://schemas.microsoft.com/office/drawing/2014/main" id="{5A27CF48-730D-4849-A0D0-748ABFE25FBF}"/>
+                <a16:creationId xmlns:a16="http://schemas.microsoft.com/office/drawing/2014/main" id="{82B5F677-BBB4-43A3-B816-532EDC7AFDDB}"/>
               </a:ext>
             </a:extLst>
           </p:cNvPr>
@@ -2052,7 +2052,7 @@
           <p:cNvPr id="13" name="">
             <a:extLst xmlns:a="http://schemas.openxmlformats.org/drawingml/2006/main">
               <a:ext uri="{FF2B5EF4-FFF2-40B4-BE49-F238E27FC236}">
-                <a16:creationId xmlns:a16="http://schemas.microsoft.com/office/drawing/2014/main" id="{E3D7F584-D082-43BA-8AB8-6E3F16AAC5A0}"/>
+                <a16:creationId xmlns:a16="http://schemas.microsoft.com/office/drawing/2014/main" id="{DEA3FE6C-6CF9-4CA3-B31E-825D928BB62A}"/>
               </a:ext>
             </a:extLst>
           </p:cNvPr>
@@ -2072,7 +2072,7 @@
             </a:avLst>
           </a:prstGeom>
           <a:solidFill xmlns:a="http://schemas.openxmlformats.org/drawingml/2006/main">
-            <a:srgbClr val="102D55"/>
+            <a:srgbClr val="F4F8FF"/>
           </a:solidFill>
           <a:ln xmlns:a="http://schemas.openxmlformats.org/drawingml/2006/main" w="9525">
             <a:solidFill>
@@ -2097,7 +2097,13 @@
           <p:nvPr/>
         </p:nvPicPr>
         <p:blipFill>
-          <a:blip xmlns:r="http://schemas.openxmlformats.org/officeDocument/2006/relationships" xmlns:a="http://schemas.openxmlformats.org/drawingml/2006/main" r:embed="Rf4e5316c8e29460e"/>
+          <a:blip xmlns:r="http://schemas.openxmlformats.org/officeDocument/2006/relationships" xmlns:a="http://schemas.openxmlformats.org/drawingml/2006/main" r:embed="R11d13e50c17248b3">
+            <a:extLst>
+              <a:ext uri="{96DAC541-7B7A-43D3-8B79-37D633B846F1}">
+                <asvg:svgBlip xmlns:asvg="http://schemas.microsoft.com/office/drawing/2016/SVG/main" r:embed="Ra5fe698596464652"/>
+              </a:ext>
+            </a:extLst>
+          </a:blip>
           <a:stretch xmlns:a="http://schemas.openxmlformats.org/drawingml/2006/main"/>
         </p:blipFill>
         <p:spPr>
@@ -2117,7 +2123,7 @@
           <p:cNvPr id="15" name="">
             <a:extLst xmlns:a="http://schemas.openxmlformats.org/drawingml/2006/main">
               <a:ext uri="{FF2B5EF4-FFF2-40B4-BE49-F238E27FC236}">
-                <a16:creationId xmlns:a16="http://schemas.microsoft.com/office/drawing/2014/main" id="{E3BC46A4-CD78-4F27-9716-30EE759389BB}"/>
+                <a16:creationId xmlns:a16="http://schemas.microsoft.com/office/drawing/2014/main" id="{6BB212ED-5654-4DF9-A4AF-04D1A00E6995}"/>
               </a:ext>
             </a:extLst>
           </p:cNvPr>
@@ -2173,7 +2179,7 @@
           <p:cNvPr id="16" name="">
             <a:extLst xmlns:a="http://schemas.openxmlformats.org/drawingml/2006/main">
               <a:ext uri="{FF2B5EF4-FFF2-40B4-BE49-F238E27FC236}">
-                <a16:creationId xmlns:a16="http://schemas.microsoft.com/office/drawing/2014/main" id="{BA4404B4-C470-4312-91FC-2A52DDAF198B}"/>
+                <a16:creationId xmlns:a16="http://schemas.microsoft.com/office/drawing/2014/main" id="{564D86F3-5A63-4B87-BAF0-2568BB48E776}"/>
               </a:ext>
             </a:extLst>
           </p:cNvPr>
@@ -2219,7 +2225,7 @@
                 <a:ea typeface="Aptos"/>
                 <a:cs typeface="Aptos"/>
               </a:rPr>
-              <a:t>jeffersonsantoskn.github.io/Trilum-Conecta/#/coday</a:t>
+              <a:t>auhauhbr.github.io/Trilum-Conecta/#/coday</a:t>
             </a:r>
           </a:p>
         </p:txBody>
@@ -2229,7 +2235,7 @@
           <p:cNvPr id="17" name="">
             <a:extLst xmlns:a="http://schemas.openxmlformats.org/drawingml/2006/main">
               <a:ext uri="{FF2B5EF4-FFF2-40B4-BE49-F238E27FC236}">
-                <a16:creationId xmlns:a16="http://schemas.microsoft.com/office/drawing/2014/main" id="{F105F846-E27B-49AF-87F3-8FD996D0790D}"/>
+                <a16:creationId xmlns:a16="http://schemas.microsoft.com/office/drawing/2014/main" id="{FD3F31C3-88F9-41E0-BE2E-567BEC7E63D5}"/>
               </a:ext>
             </a:extLst>
           </p:cNvPr>
@@ -2264,7 +2270,7 @@
           <p:cNvPr id="18" name="">
             <a:extLst xmlns:a="http://schemas.openxmlformats.org/drawingml/2006/main">
               <a:ext uri="{FF2B5EF4-FFF2-40B4-BE49-F238E27FC236}">
-                <a16:creationId xmlns:a16="http://schemas.microsoft.com/office/drawing/2014/main" id="{BBBEBE67-8484-405E-972D-B75F9789B11A}"/>
+                <a16:creationId xmlns:a16="http://schemas.microsoft.com/office/drawing/2014/main" id="{1C8BF6DE-ED6E-4C3B-A5E7-9491653D1D16}"/>
               </a:ext>
             </a:extLst>
           </p:cNvPr>
@@ -2318,7 +2324,7 @@
     </p:spTree>
     <p:extLst>
       <p:ext uri="{BB962C8B-B14F-4D97-AF65-F5344CB8AC3E}">
-        <p14:creationId xmlns:p14="http://schemas.microsoft.com/office/powerpoint/2010/main" val="1819718565"/>
+        <p14:creationId xmlns:p14="http://schemas.microsoft.com/office/powerpoint/2010/main" val="107841971"/>
       </p:ext>
     </p:extLst>
   </p:cSld>
@@ -2349,7 +2355,7 @@
           <p:cNvPr id="1" name="">
             <a:extLst xmlns:a="http://schemas.openxmlformats.org/drawingml/2006/main">
               <a:ext uri="{FF2B5EF4-FFF2-40B4-BE49-F238E27FC236}">
-                <a16:creationId xmlns:a16="http://schemas.microsoft.com/office/drawing/2014/main" id="{EA2698D4-D273-4AFF-A370-2C5C753B1D1C}"/>
+                <a16:creationId xmlns:a16="http://schemas.microsoft.com/office/drawing/2014/main" id="{46F9821B-FF24-4489-AF67-B1F37DC829B9}"/>
               </a:ext>
             </a:extLst>
           </p:cNvPr>
@@ -2405,7 +2411,7 @@
           <p:cNvPr id="2" name="">
             <a:extLst xmlns:a="http://schemas.openxmlformats.org/drawingml/2006/main">
               <a:ext uri="{FF2B5EF4-FFF2-40B4-BE49-F238E27FC236}">
-                <a16:creationId xmlns:a16="http://schemas.microsoft.com/office/drawing/2014/main" id="{9A91079D-8F6E-4F97-AEB2-1251DB1BBCC5}"/>
+                <a16:creationId xmlns:a16="http://schemas.microsoft.com/office/drawing/2014/main" id="{6906759F-7EDE-4734-BF41-85C35AE8E6CE}"/>
               </a:ext>
             </a:extLst>
           </p:cNvPr>
@@ -2461,7 +2467,7 @@
           <p:cNvPr id="3" name="">
             <a:extLst xmlns:a="http://schemas.openxmlformats.org/drawingml/2006/main">
               <a:ext uri="{FF2B5EF4-FFF2-40B4-BE49-F238E27FC236}">
-                <a16:creationId xmlns:a16="http://schemas.microsoft.com/office/drawing/2014/main" id="{6B213DF0-2BEE-4E2B-8A3B-2B679DCD6C3B}"/>
+                <a16:creationId xmlns:a16="http://schemas.microsoft.com/office/drawing/2014/main" id="{AD056B1E-64FF-4E17-B2D3-ADF07E3DC174}"/>
               </a:ext>
             </a:extLst>
           </p:cNvPr>
@@ -2517,7 +2523,7 @@
           <p:cNvPr id="4" name="">
             <a:extLst xmlns:a="http://schemas.openxmlformats.org/drawingml/2006/main">
               <a:ext uri="{FF2B5EF4-FFF2-40B4-BE49-F238E27FC236}">
-                <a16:creationId xmlns:a16="http://schemas.microsoft.com/office/drawing/2014/main" id="{E3AF2EFE-63EA-4EC6-BFE7-EA6FD834824C}"/>
+                <a16:creationId xmlns:a16="http://schemas.microsoft.com/office/drawing/2014/main" id="{FE340669-04C3-4C38-909F-5FF2807AC0CB}"/>
               </a:ext>
             </a:extLst>
           </p:cNvPr>
@@ -2550,7 +2556,7 @@
           <p:cNvPr id="5" name="">
             <a:extLst xmlns:a="http://schemas.openxmlformats.org/drawingml/2006/main">
               <a:ext uri="{FF2B5EF4-FFF2-40B4-BE49-F238E27FC236}">
-                <a16:creationId xmlns:a16="http://schemas.microsoft.com/office/drawing/2014/main" id="{AF807181-1949-42F4-9EEB-0FAEE38A4C00}"/>
+                <a16:creationId xmlns:a16="http://schemas.microsoft.com/office/drawing/2014/main" id="{5C7104BE-45D0-4B99-A284-A862170FA967}"/>
               </a:ext>
             </a:extLst>
           </p:cNvPr>
@@ -2606,7 +2612,7 @@
           <p:cNvPr id="6" name="">
             <a:extLst xmlns:a="http://schemas.openxmlformats.org/drawingml/2006/main">
               <a:ext uri="{FF2B5EF4-FFF2-40B4-BE49-F238E27FC236}">
-                <a16:creationId xmlns:a16="http://schemas.microsoft.com/office/drawing/2014/main" id="{5E3AB394-063E-4260-AE78-FA24280C5568}"/>
+                <a16:creationId xmlns:a16="http://schemas.microsoft.com/office/drawing/2014/main" id="{8F181AB4-C1C3-4CB6-ABD3-8025A5E83153}"/>
               </a:ext>
             </a:extLst>
           </p:cNvPr>
@@ -2647,7 +2653,7 @@
           <p:cNvPr id="7" name="">
             <a:extLst xmlns:a="http://schemas.openxmlformats.org/drawingml/2006/main">
               <a:ext uri="{FF2B5EF4-FFF2-40B4-BE49-F238E27FC236}">
-                <a16:creationId xmlns:a16="http://schemas.microsoft.com/office/drawing/2014/main" id="{97A764C2-824A-4F88-99CD-89904215B752}"/>
+                <a16:creationId xmlns:a16="http://schemas.microsoft.com/office/drawing/2014/main" id="{C321EFBC-4C2A-4F7E-87CB-17BDB4411780}"/>
               </a:ext>
             </a:extLst>
           </p:cNvPr>
@@ -2688,7 +2694,7 @@
           <p:cNvPr id="8" name="">
             <a:extLst xmlns:a="http://schemas.openxmlformats.org/drawingml/2006/main">
               <a:ext uri="{FF2B5EF4-FFF2-40B4-BE49-F238E27FC236}">
-                <a16:creationId xmlns:a16="http://schemas.microsoft.com/office/drawing/2014/main" id="{615735E5-B38F-41FB-AB1A-B0DB51A36A2D}"/>
+                <a16:creationId xmlns:a16="http://schemas.microsoft.com/office/drawing/2014/main" id="{E1CFBCD3-0EAB-4C67-9D52-C68B3B92C1B5}"/>
               </a:ext>
             </a:extLst>
           </p:cNvPr>
@@ -2723,7 +2729,7 @@
           <p:cNvPr id="9" name="">
             <a:extLst xmlns:a="http://schemas.openxmlformats.org/drawingml/2006/main">
               <a:ext uri="{FF2B5EF4-FFF2-40B4-BE49-F238E27FC236}">
-                <a16:creationId xmlns:a16="http://schemas.microsoft.com/office/drawing/2014/main" id="{05C706E7-5DB6-410F-853C-7167A152C472}"/>
+                <a16:creationId xmlns:a16="http://schemas.microsoft.com/office/drawing/2014/main" id="{7C353B69-195B-4E59-8E58-A85D63BBD966}"/>
               </a:ext>
             </a:extLst>
           </p:cNvPr>
@@ -2779,7 +2785,7 @@
           <p:cNvPr id="10" name="">
             <a:extLst xmlns:a="http://schemas.openxmlformats.org/drawingml/2006/main">
               <a:ext uri="{FF2B5EF4-FFF2-40B4-BE49-F238E27FC236}">
-                <a16:creationId xmlns:a16="http://schemas.microsoft.com/office/drawing/2014/main" id="{CB44E41C-B6A2-4FDC-BB7E-C482AED8F4F3}"/>
+                <a16:creationId xmlns:a16="http://schemas.microsoft.com/office/drawing/2014/main" id="{20E16673-C182-437D-AD6A-3FB60EF900C1}"/>
               </a:ext>
             </a:extLst>
           </p:cNvPr>
@@ -2858,7 +2864,7 @@
           <p:cNvPr id="11" name="">
             <a:extLst xmlns:a="http://schemas.openxmlformats.org/drawingml/2006/main">
               <a:ext uri="{FF2B5EF4-FFF2-40B4-BE49-F238E27FC236}">
-                <a16:creationId xmlns:a16="http://schemas.microsoft.com/office/drawing/2014/main" id="{E3FBDF83-94B3-4917-822B-40B77DDF0C46}"/>
+                <a16:creationId xmlns:a16="http://schemas.microsoft.com/office/drawing/2014/main" id="{B38DFF49-0159-42A7-AD3B-B44C10865CCE}"/>
               </a:ext>
             </a:extLst>
           </p:cNvPr>
@@ -2899,7 +2905,7 @@
           <p:cNvPr id="12" name="">
             <a:extLst xmlns:a="http://schemas.openxmlformats.org/drawingml/2006/main">
               <a:ext uri="{FF2B5EF4-FFF2-40B4-BE49-F238E27FC236}">
-                <a16:creationId xmlns:a16="http://schemas.microsoft.com/office/drawing/2014/main" id="{207971D6-DD72-4FA1-928B-5D495925FFD0}"/>
+                <a16:creationId xmlns:a16="http://schemas.microsoft.com/office/drawing/2014/main" id="{9D429003-FC77-4E6A-8A68-64A37E573848}"/>
               </a:ext>
             </a:extLst>
           </p:cNvPr>
@@ -2934,7 +2940,7 @@
           <p:cNvPr id="13" name="">
             <a:extLst xmlns:a="http://schemas.openxmlformats.org/drawingml/2006/main">
               <a:ext uri="{FF2B5EF4-FFF2-40B4-BE49-F238E27FC236}">
-                <a16:creationId xmlns:a16="http://schemas.microsoft.com/office/drawing/2014/main" id="{57AF2A3B-683A-4653-9B87-CAAAA5FDCC7F}"/>
+                <a16:creationId xmlns:a16="http://schemas.microsoft.com/office/drawing/2014/main" id="{36324C4B-3B0F-480A-80E6-3EA91D3F34D2}"/>
               </a:ext>
             </a:extLst>
           </p:cNvPr>
@@ -2990,7 +2996,7 @@
           <p:cNvPr id="14" name="">
             <a:extLst xmlns:a="http://schemas.openxmlformats.org/drawingml/2006/main">
               <a:ext uri="{FF2B5EF4-FFF2-40B4-BE49-F238E27FC236}">
-                <a16:creationId xmlns:a16="http://schemas.microsoft.com/office/drawing/2014/main" id="{F1115AE7-3A7D-4496-AE17-2A62EC0A8416}"/>
+                <a16:creationId xmlns:a16="http://schemas.microsoft.com/office/drawing/2014/main" id="{B8D49A01-BE0E-4291-ADA4-D1A53B3D2D78}"/>
               </a:ext>
             </a:extLst>
           </p:cNvPr>
@@ -3046,7 +3052,7 @@
           <p:cNvPr id="15" name="">
             <a:extLst xmlns:a="http://schemas.openxmlformats.org/drawingml/2006/main">
               <a:ext uri="{FF2B5EF4-FFF2-40B4-BE49-F238E27FC236}">
-                <a16:creationId xmlns:a16="http://schemas.microsoft.com/office/drawing/2014/main" id="{6A95D864-BDE7-4DD8-ABAB-49D9BAAE8836}"/>
+                <a16:creationId xmlns:a16="http://schemas.microsoft.com/office/drawing/2014/main" id="{F6A25DE4-9B4B-4D0C-8A4C-6CC130C3909D}"/>
               </a:ext>
             </a:extLst>
           </p:cNvPr>
@@ -3102,7 +3108,7 @@
           <p:cNvPr id="16" name="">
             <a:extLst xmlns:a="http://schemas.openxmlformats.org/drawingml/2006/main">
               <a:ext uri="{FF2B5EF4-FFF2-40B4-BE49-F238E27FC236}">
-                <a16:creationId xmlns:a16="http://schemas.microsoft.com/office/drawing/2014/main" id="{ECF42F4D-7679-4C04-90AE-EB60F947E7A5}"/>
+                <a16:creationId xmlns:a16="http://schemas.microsoft.com/office/drawing/2014/main" id="{D5A16F53-A363-4BEE-A0C0-59C51A1EF60E}"/>
               </a:ext>
             </a:extLst>
           </p:cNvPr>
@@ -3143,7 +3149,7 @@
           <p:cNvPr id="17" name="">
             <a:extLst xmlns:a="http://schemas.openxmlformats.org/drawingml/2006/main">
               <a:ext uri="{FF2B5EF4-FFF2-40B4-BE49-F238E27FC236}">
-                <a16:creationId xmlns:a16="http://schemas.microsoft.com/office/drawing/2014/main" id="{2920F482-AF31-45E9-9EC4-F58664D4FF31}"/>
+                <a16:creationId xmlns:a16="http://schemas.microsoft.com/office/drawing/2014/main" id="{EDEB0E64-539F-4741-9169-8743229540DF}"/>
               </a:ext>
             </a:extLst>
           </p:cNvPr>
@@ -3178,7 +3184,7 @@
           <p:cNvPr id="18" name="">
             <a:extLst xmlns:a="http://schemas.openxmlformats.org/drawingml/2006/main">
               <a:ext uri="{FF2B5EF4-FFF2-40B4-BE49-F238E27FC236}">
-                <a16:creationId xmlns:a16="http://schemas.microsoft.com/office/drawing/2014/main" id="{32FE03A1-2CDB-47C2-A0BD-EFE67BB663CC}"/>
+                <a16:creationId xmlns:a16="http://schemas.microsoft.com/office/drawing/2014/main" id="{1A0E921F-670B-4CE0-B9AF-3633F7137077}"/>
               </a:ext>
             </a:extLst>
           </p:cNvPr>
@@ -3234,7 +3240,7 @@
           <p:cNvPr id="19" name="">
             <a:extLst xmlns:a="http://schemas.openxmlformats.org/drawingml/2006/main">
               <a:ext uri="{FF2B5EF4-FFF2-40B4-BE49-F238E27FC236}">
-                <a16:creationId xmlns:a16="http://schemas.microsoft.com/office/drawing/2014/main" id="{96C16615-53A6-4E70-BE49-F9289E9B6FD7}"/>
+                <a16:creationId xmlns:a16="http://schemas.microsoft.com/office/drawing/2014/main" id="{C9B6981E-8203-4AA5-ACD9-C5267EEC02FA}"/>
               </a:ext>
             </a:extLst>
           </p:cNvPr>
@@ -3290,7 +3296,7 @@
           <p:cNvPr id="20" name="">
             <a:extLst xmlns:a="http://schemas.openxmlformats.org/drawingml/2006/main">
               <a:ext uri="{FF2B5EF4-FFF2-40B4-BE49-F238E27FC236}">
-                <a16:creationId xmlns:a16="http://schemas.microsoft.com/office/drawing/2014/main" id="{FAAE6720-B7F3-4843-849E-7018BD167934}"/>
+                <a16:creationId xmlns:a16="http://schemas.microsoft.com/office/drawing/2014/main" id="{2DD42E21-942A-439A-A057-96F3EF81A8F0}"/>
               </a:ext>
             </a:extLst>
           </p:cNvPr>
@@ -3346,7 +3352,7 @@
           <p:cNvPr id="21" name="">
             <a:extLst xmlns:a="http://schemas.openxmlformats.org/drawingml/2006/main">
               <a:ext uri="{FF2B5EF4-FFF2-40B4-BE49-F238E27FC236}">
-                <a16:creationId xmlns:a16="http://schemas.microsoft.com/office/drawing/2014/main" id="{B7D06503-F100-44CF-A750-432CFB2FE9E2}"/>
+                <a16:creationId xmlns:a16="http://schemas.microsoft.com/office/drawing/2014/main" id="{4BAC36DD-FAF4-4077-93AE-91EE87323E53}"/>
               </a:ext>
             </a:extLst>
           </p:cNvPr>
@@ -3381,7 +3387,7 @@
           <p:cNvPr id="22" name="">
             <a:extLst xmlns:a="http://schemas.openxmlformats.org/drawingml/2006/main">
               <a:ext uri="{FF2B5EF4-FFF2-40B4-BE49-F238E27FC236}">
-                <a16:creationId xmlns:a16="http://schemas.microsoft.com/office/drawing/2014/main" id="{4CFE8022-8E78-4FAE-8859-2F4A295A9354}"/>
+                <a16:creationId xmlns:a16="http://schemas.microsoft.com/office/drawing/2014/main" id="{0F88BCA6-DD04-4393-B0F5-DF57D9144385}"/>
               </a:ext>
             </a:extLst>
           </p:cNvPr>
@@ -3437,7 +3443,7 @@
           <p:cNvPr id="23" name="">
             <a:extLst xmlns:a="http://schemas.openxmlformats.org/drawingml/2006/main">
               <a:ext uri="{FF2B5EF4-FFF2-40B4-BE49-F238E27FC236}">
-                <a16:creationId xmlns:a16="http://schemas.microsoft.com/office/drawing/2014/main" id="{14E85C53-960C-422B-9606-FF158D35C3AE}"/>
+                <a16:creationId xmlns:a16="http://schemas.microsoft.com/office/drawing/2014/main" id="{21319801-9614-4C77-B79D-4010A910DDDF}"/>
               </a:ext>
             </a:extLst>
           </p:cNvPr>
@@ -3516,7 +3522,7 @@
           <p:cNvPr id="24" name="">
             <a:extLst xmlns:a="http://schemas.openxmlformats.org/drawingml/2006/main">
               <a:ext uri="{FF2B5EF4-FFF2-40B4-BE49-F238E27FC236}">
-                <a16:creationId xmlns:a16="http://schemas.microsoft.com/office/drawing/2014/main" id="{146BB98B-08F2-4B6C-9E99-5E4D285A2E35}"/>
+                <a16:creationId xmlns:a16="http://schemas.microsoft.com/office/drawing/2014/main" id="{ED3A2C93-AF53-4DB6-844A-3D7E4263019F}"/>
               </a:ext>
             </a:extLst>
           </p:cNvPr>
@@ -3557,7 +3563,7 @@
           <p:cNvPr id="25" name="">
             <a:extLst xmlns:a="http://schemas.openxmlformats.org/drawingml/2006/main">
               <a:ext uri="{FF2B5EF4-FFF2-40B4-BE49-F238E27FC236}">
-                <a16:creationId xmlns:a16="http://schemas.microsoft.com/office/drawing/2014/main" id="{97311DD6-4EA1-478E-AE3A-7FAAC3C9D175}"/>
+                <a16:creationId xmlns:a16="http://schemas.microsoft.com/office/drawing/2014/main" id="{D19DB663-7ACB-4441-87EB-1F0BA2D77D27}"/>
               </a:ext>
             </a:extLst>
           </p:cNvPr>
@@ -3592,7 +3598,7 @@
           <p:cNvPr id="26" name="">
             <a:extLst xmlns:a="http://schemas.openxmlformats.org/drawingml/2006/main">
               <a:ext uri="{FF2B5EF4-FFF2-40B4-BE49-F238E27FC236}">
-                <a16:creationId xmlns:a16="http://schemas.microsoft.com/office/drawing/2014/main" id="{F6F0FC9F-140E-4470-ACB0-33A4BBFFC5E3}"/>
+                <a16:creationId xmlns:a16="http://schemas.microsoft.com/office/drawing/2014/main" id="{B89043EA-A6C5-4A82-96A4-680283BDC314}"/>
               </a:ext>
             </a:extLst>
           </p:cNvPr>
@@ -3648,7 +3654,7 @@
           <p:cNvPr id="27" name="">
             <a:extLst xmlns:a="http://schemas.openxmlformats.org/drawingml/2006/main">
               <a:ext uri="{FF2B5EF4-FFF2-40B4-BE49-F238E27FC236}">
-                <a16:creationId xmlns:a16="http://schemas.microsoft.com/office/drawing/2014/main" id="{F136F8B0-0ACE-4355-B5A1-8FDA57806468}"/>
+                <a16:creationId xmlns:a16="http://schemas.microsoft.com/office/drawing/2014/main" id="{3F91F122-4F85-4A6E-AF54-82CAA7A3E63B}"/>
               </a:ext>
             </a:extLst>
           </p:cNvPr>
@@ -3704,7 +3710,7 @@
           <p:cNvPr id="28" name="">
             <a:extLst xmlns:a="http://schemas.openxmlformats.org/drawingml/2006/main">
               <a:ext uri="{FF2B5EF4-FFF2-40B4-BE49-F238E27FC236}">
-                <a16:creationId xmlns:a16="http://schemas.microsoft.com/office/drawing/2014/main" id="{95E3D7F9-40E8-4C7E-897C-7DB8B5C1625F}"/>
+                <a16:creationId xmlns:a16="http://schemas.microsoft.com/office/drawing/2014/main" id="{22D8CF63-112B-4AC0-843E-89CA55658191}"/>
               </a:ext>
             </a:extLst>
           </p:cNvPr>
@@ -3760,7 +3766,7 @@
           <p:cNvPr id="29" name="">
             <a:extLst xmlns:a="http://schemas.openxmlformats.org/drawingml/2006/main">
               <a:ext uri="{FF2B5EF4-FFF2-40B4-BE49-F238E27FC236}">
-                <a16:creationId xmlns:a16="http://schemas.microsoft.com/office/drawing/2014/main" id="{068AA0A0-7028-4F3E-A30A-CD962C46F75A}"/>
+                <a16:creationId xmlns:a16="http://schemas.microsoft.com/office/drawing/2014/main" id="{F105B79C-AF37-465D-A56C-9BE59885C9B6}"/>
               </a:ext>
             </a:extLst>
           </p:cNvPr>
@@ -3801,7 +3807,7 @@
           <p:cNvPr id="30" name="">
             <a:extLst xmlns:a="http://schemas.openxmlformats.org/drawingml/2006/main">
               <a:ext uri="{FF2B5EF4-FFF2-40B4-BE49-F238E27FC236}">
-                <a16:creationId xmlns:a16="http://schemas.microsoft.com/office/drawing/2014/main" id="{D08D684C-CFFA-4BA5-913A-E442547A0446}"/>
+                <a16:creationId xmlns:a16="http://schemas.microsoft.com/office/drawing/2014/main" id="{CEB7C8EA-F189-4C3B-8103-D7F4D2562070}"/>
               </a:ext>
             </a:extLst>
           </p:cNvPr>
@@ -3836,7 +3842,7 @@
           <p:cNvPr id="31" name="">
             <a:extLst xmlns:a="http://schemas.openxmlformats.org/drawingml/2006/main">
               <a:ext uri="{FF2B5EF4-FFF2-40B4-BE49-F238E27FC236}">
-                <a16:creationId xmlns:a16="http://schemas.microsoft.com/office/drawing/2014/main" id="{38132205-D1E2-4ED7-BDFA-F9F60ABA947E}"/>
+                <a16:creationId xmlns:a16="http://schemas.microsoft.com/office/drawing/2014/main" id="{2CB245AF-630F-413F-9585-C1527F038872}"/>
               </a:ext>
             </a:extLst>
           </p:cNvPr>
@@ -3892,7 +3898,7 @@
           <p:cNvPr id="32" name="">
             <a:extLst xmlns:a="http://schemas.openxmlformats.org/drawingml/2006/main">
               <a:ext uri="{FF2B5EF4-FFF2-40B4-BE49-F238E27FC236}">
-                <a16:creationId xmlns:a16="http://schemas.microsoft.com/office/drawing/2014/main" id="{645E30F9-B048-4A9A-8B1F-FF2CF35B308E}"/>
+                <a16:creationId xmlns:a16="http://schemas.microsoft.com/office/drawing/2014/main" id="{394BE6DD-9044-4997-A0A9-8128A2254A7E}"/>
               </a:ext>
             </a:extLst>
           </p:cNvPr>
@@ -3948,7 +3954,7 @@
           <p:cNvPr id="33" name="">
             <a:extLst xmlns:a="http://schemas.openxmlformats.org/drawingml/2006/main">
               <a:ext uri="{FF2B5EF4-FFF2-40B4-BE49-F238E27FC236}">
-                <a16:creationId xmlns:a16="http://schemas.microsoft.com/office/drawing/2014/main" id="{8AC98F78-8173-456F-91CA-F15ED791843B}"/>
+                <a16:creationId xmlns:a16="http://schemas.microsoft.com/office/drawing/2014/main" id="{A08F6A52-C92A-49FC-B8BC-6D76F3F28DE8}"/>
               </a:ext>
             </a:extLst>
           </p:cNvPr>
@@ -4004,7 +4010,7 @@
           <p:cNvPr id="34" name="">
             <a:extLst xmlns:a="http://schemas.openxmlformats.org/drawingml/2006/main">
               <a:ext uri="{FF2B5EF4-FFF2-40B4-BE49-F238E27FC236}">
-                <a16:creationId xmlns:a16="http://schemas.microsoft.com/office/drawing/2014/main" id="{B03219C2-3E19-4180-AF98-D10772D6CF0C}"/>
+                <a16:creationId xmlns:a16="http://schemas.microsoft.com/office/drawing/2014/main" id="{BE0B8B66-688D-4C86-8C6D-1D7ABCC66BE2}"/>
               </a:ext>
             </a:extLst>
           </p:cNvPr>
@@ -4045,7 +4051,7 @@
           <p:cNvPr id="35" name="">
             <a:extLst xmlns:a="http://schemas.openxmlformats.org/drawingml/2006/main">
               <a:ext uri="{FF2B5EF4-FFF2-40B4-BE49-F238E27FC236}">
-                <a16:creationId xmlns:a16="http://schemas.microsoft.com/office/drawing/2014/main" id="{8D0CE0BC-0981-44DF-9E35-801CB99204C2}"/>
+                <a16:creationId xmlns:a16="http://schemas.microsoft.com/office/drawing/2014/main" id="{A08AB33B-71C5-4DFE-B397-695AD07D0DAC}"/>
               </a:ext>
             </a:extLst>
           </p:cNvPr>
@@ -4101,7 +4107,7 @@
           <p:cNvPr id="36" name="">
             <a:extLst xmlns:a="http://schemas.openxmlformats.org/drawingml/2006/main">
               <a:ext uri="{FF2B5EF4-FFF2-40B4-BE49-F238E27FC236}">
-                <a16:creationId xmlns:a16="http://schemas.microsoft.com/office/drawing/2014/main" id="{FA0330DC-7671-47C2-8158-252CAD8180A9}"/>
+                <a16:creationId xmlns:a16="http://schemas.microsoft.com/office/drawing/2014/main" id="{C33E84E0-F33B-489A-8FC5-4884FBF02B11}"/>
               </a:ext>
             </a:extLst>
           </p:cNvPr>
@@ -4155,7 +4161,7 @@
     </p:spTree>
     <p:extLst>
       <p:ext uri="{BB962C8B-B14F-4D97-AF65-F5344CB8AC3E}">
-        <p14:creationId xmlns:p14="http://schemas.microsoft.com/office/powerpoint/2010/main" val="768214326"/>
+        <p14:creationId xmlns:p14="http://schemas.microsoft.com/office/powerpoint/2010/main" val="1488120542"/>
       </p:ext>
     </p:extLst>
   </p:cSld>
@@ -4186,7 +4192,7 @@
           <p:cNvPr id="1" name="">
             <a:extLst xmlns:a="http://schemas.openxmlformats.org/drawingml/2006/main">
               <a:ext uri="{FF2B5EF4-FFF2-40B4-BE49-F238E27FC236}">
-                <a16:creationId xmlns:a16="http://schemas.microsoft.com/office/drawing/2014/main" id="{581699CF-CD12-46A2-A974-8CF34C69AE97}"/>
+                <a16:creationId xmlns:a16="http://schemas.microsoft.com/office/drawing/2014/main" id="{AC72DAE9-1909-4FD0-ACD3-567F4ACED8E7}"/>
               </a:ext>
             </a:extLst>
           </p:cNvPr>
@@ -4242,7 +4248,7 @@
           <p:cNvPr id="2" name="">
             <a:extLst xmlns:a="http://schemas.openxmlformats.org/drawingml/2006/main">
               <a:ext uri="{FF2B5EF4-FFF2-40B4-BE49-F238E27FC236}">
-                <a16:creationId xmlns:a16="http://schemas.microsoft.com/office/drawing/2014/main" id="{E61751A6-713A-4465-8205-6D9998FB5203}"/>
+                <a16:creationId xmlns:a16="http://schemas.microsoft.com/office/drawing/2014/main" id="{08CAAC29-71D6-44A3-87B7-BD81C8A7CE65}"/>
               </a:ext>
             </a:extLst>
           </p:cNvPr>
@@ -4298,7 +4304,7 @@
           <p:cNvPr id="3" name="">
             <a:extLst xmlns:a="http://schemas.openxmlformats.org/drawingml/2006/main">
               <a:ext uri="{FF2B5EF4-FFF2-40B4-BE49-F238E27FC236}">
-                <a16:creationId xmlns:a16="http://schemas.microsoft.com/office/drawing/2014/main" id="{CA03439A-3121-41CB-A40D-6C047A898BA6}"/>
+                <a16:creationId xmlns:a16="http://schemas.microsoft.com/office/drawing/2014/main" id="{0C3639C6-814F-439D-A71D-31A3D7228367}"/>
               </a:ext>
             </a:extLst>
           </p:cNvPr>
@@ -4354,7 +4360,7 @@
           <p:cNvPr id="4" name="">
             <a:extLst xmlns:a="http://schemas.openxmlformats.org/drawingml/2006/main">
               <a:ext uri="{FF2B5EF4-FFF2-40B4-BE49-F238E27FC236}">
-                <a16:creationId xmlns:a16="http://schemas.microsoft.com/office/drawing/2014/main" id="{76AC9B3C-887C-43FA-B92D-247122D48E6F}"/>
+                <a16:creationId xmlns:a16="http://schemas.microsoft.com/office/drawing/2014/main" id="{E8BF3BAE-8855-4396-AAD1-E16138642474}"/>
               </a:ext>
             </a:extLst>
           </p:cNvPr>
@@ -4387,7 +4393,7 @@
           <p:cNvPr id="5" name="">
             <a:extLst xmlns:a="http://schemas.openxmlformats.org/drawingml/2006/main">
               <a:ext uri="{FF2B5EF4-FFF2-40B4-BE49-F238E27FC236}">
-                <a16:creationId xmlns:a16="http://schemas.microsoft.com/office/drawing/2014/main" id="{EDDB5C36-4B1A-4484-9899-90E9007D103F}"/>
+                <a16:creationId xmlns:a16="http://schemas.microsoft.com/office/drawing/2014/main" id="{F23E91E8-48CF-448B-AB62-C80DFF66A2F4}"/>
               </a:ext>
             </a:extLst>
           </p:cNvPr>
@@ -4443,7 +4449,7 @@
           <p:cNvPr id="6" name="">
             <a:extLst xmlns:a="http://schemas.openxmlformats.org/drawingml/2006/main">
               <a:ext uri="{FF2B5EF4-FFF2-40B4-BE49-F238E27FC236}">
-                <a16:creationId xmlns:a16="http://schemas.microsoft.com/office/drawing/2014/main" id="{E5471EF3-1EE6-4BB9-BED1-F9D1B8922C1A}"/>
+                <a16:creationId xmlns:a16="http://schemas.microsoft.com/office/drawing/2014/main" id="{65D117EF-AC12-4BCD-ADA5-E919DFF7748C}"/>
               </a:ext>
             </a:extLst>
           </p:cNvPr>
@@ -4484,7 +4490,7 @@
           <p:cNvPr id="7" name="">
             <a:extLst xmlns:a="http://schemas.openxmlformats.org/drawingml/2006/main">
               <a:ext uri="{FF2B5EF4-FFF2-40B4-BE49-F238E27FC236}">
-                <a16:creationId xmlns:a16="http://schemas.microsoft.com/office/drawing/2014/main" id="{B2F69F4B-2EB7-4BF0-8636-04E06B3AF033}"/>
+                <a16:creationId xmlns:a16="http://schemas.microsoft.com/office/drawing/2014/main" id="{DD3080CF-B172-43F6-937F-A4260CE1C0BF}"/>
               </a:ext>
             </a:extLst>
           </p:cNvPr>
@@ -4529,7 +4535,7 @@
           <p:nvPr/>
         </p:nvPicPr>
         <p:blipFill>
-          <a:blip xmlns:r="http://schemas.openxmlformats.org/officeDocument/2006/relationships" xmlns:a="http://schemas.openxmlformats.org/drawingml/2006/main" r:embed="R89d31f07d45a4694"/>
+          <a:blip xmlns:r="http://schemas.openxmlformats.org/officeDocument/2006/relationships" xmlns:a="http://schemas.openxmlformats.org/drawingml/2006/main" r:embed="R4173c9e5c950461a"/>
           <a:srcRect xmlns:a="http://schemas.openxmlformats.org/drawingml/2006/main" l="11842" t="0" r="11842" b="0"/>
           <a:stretch xmlns:a="http://schemas.openxmlformats.org/drawingml/2006/main">
             <a:fillRect l="0" t="0" r="0" b="0"/>
@@ -4552,7 +4558,7 @@
           <p:cNvPr id="9" name="">
             <a:extLst xmlns:a="http://schemas.openxmlformats.org/drawingml/2006/main">
               <a:ext uri="{FF2B5EF4-FFF2-40B4-BE49-F238E27FC236}">
-                <a16:creationId xmlns:a16="http://schemas.microsoft.com/office/drawing/2014/main" id="{17809A73-7063-44BD-8FD1-6201C8F9A05E}"/>
+                <a16:creationId xmlns:a16="http://schemas.microsoft.com/office/drawing/2014/main" id="{87ED308B-E0A9-47A8-83BA-D8F10F7634AC}"/>
               </a:ext>
             </a:extLst>
           </p:cNvPr>
@@ -4587,7 +4593,7 @@
           <p:cNvPr id="10" name="">
             <a:extLst xmlns:a="http://schemas.openxmlformats.org/drawingml/2006/main">
               <a:ext uri="{FF2B5EF4-FFF2-40B4-BE49-F238E27FC236}">
-                <a16:creationId xmlns:a16="http://schemas.microsoft.com/office/drawing/2014/main" id="{692D1F39-23C2-43FF-8986-8FBBDAC0C3D7}"/>
+                <a16:creationId xmlns:a16="http://schemas.microsoft.com/office/drawing/2014/main" id="{E075797B-CC59-495A-92FD-97734A7D6CAA}"/>
               </a:ext>
             </a:extLst>
           </p:cNvPr>
@@ -4643,7 +4649,7 @@
           <p:cNvPr id="11" name="">
             <a:extLst xmlns:a="http://schemas.openxmlformats.org/drawingml/2006/main">
               <a:ext uri="{FF2B5EF4-FFF2-40B4-BE49-F238E27FC236}">
-                <a16:creationId xmlns:a16="http://schemas.microsoft.com/office/drawing/2014/main" id="{F7AE22CE-5E11-4893-B06C-E14380B4B822}"/>
+                <a16:creationId xmlns:a16="http://schemas.microsoft.com/office/drawing/2014/main" id="{4E1C45AB-4D21-4928-B837-873E0102FDE3}"/>
               </a:ext>
             </a:extLst>
           </p:cNvPr>
@@ -4699,7 +4705,7 @@
           <p:cNvPr id="12" name="">
             <a:extLst xmlns:a="http://schemas.openxmlformats.org/drawingml/2006/main">
               <a:ext uri="{FF2B5EF4-FFF2-40B4-BE49-F238E27FC236}">
-                <a16:creationId xmlns:a16="http://schemas.microsoft.com/office/drawing/2014/main" id="{8720B55E-3F24-4295-8ACD-CBB4463D6294}"/>
+                <a16:creationId xmlns:a16="http://schemas.microsoft.com/office/drawing/2014/main" id="{9C47D36E-87C5-42A9-9551-6B1375195DC7}"/>
               </a:ext>
             </a:extLst>
           </p:cNvPr>
@@ -4755,7 +4761,7 @@
           <p:cNvPr id="13" name="">
             <a:extLst xmlns:a="http://schemas.openxmlformats.org/drawingml/2006/main">
               <a:ext uri="{FF2B5EF4-FFF2-40B4-BE49-F238E27FC236}">
-                <a16:creationId xmlns:a16="http://schemas.microsoft.com/office/drawing/2014/main" id="{D30651EE-2273-47F9-A89C-467B4BD07DB8}"/>
+                <a16:creationId xmlns:a16="http://schemas.microsoft.com/office/drawing/2014/main" id="{62366C5F-CF34-4FD9-A572-E64688C28166}"/>
               </a:ext>
             </a:extLst>
           </p:cNvPr>
@@ -4796,7 +4802,7 @@
           <p:cNvPr id="14" name="">
             <a:extLst xmlns:a="http://schemas.openxmlformats.org/drawingml/2006/main">
               <a:ext uri="{FF2B5EF4-FFF2-40B4-BE49-F238E27FC236}">
-                <a16:creationId xmlns:a16="http://schemas.microsoft.com/office/drawing/2014/main" id="{EA02455A-AE75-4E1B-9287-D8FFB8E2339B}"/>
+                <a16:creationId xmlns:a16="http://schemas.microsoft.com/office/drawing/2014/main" id="{39EBFBA8-A534-495C-B694-D583F6D2B716}"/>
               </a:ext>
             </a:extLst>
           </p:cNvPr>
@@ -4841,7 +4847,7 @@
           <p:nvPr/>
         </p:nvPicPr>
         <p:blipFill>
-          <a:blip xmlns:r="http://schemas.openxmlformats.org/officeDocument/2006/relationships" xmlns:a="http://schemas.openxmlformats.org/drawingml/2006/main" r:embed="R31dbcdf5e8014224"/>
+          <a:blip xmlns:r="http://schemas.openxmlformats.org/officeDocument/2006/relationships" xmlns:a="http://schemas.openxmlformats.org/drawingml/2006/main" r:embed="R75faa7cf47c54ac2"/>
           <a:srcRect xmlns:a="http://schemas.openxmlformats.org/drawingml/2006/main" l="12462" t="0" r="12462" b="0"/>
           <a:stretch xmlns:a="http://schemas.openxmlformats.org/drawingml/2006/main">
             <a:fillRect l="0" t="0" r="0" b="0"/>
@@ -4864,7 +4870,7 @@
           <p:cNvPr id="16" name="">
             <a:extLst xmlns:a="http://schemas.openxmlformats.org/drawingml/2006/main">
               <a:ext uri="{FF2B5EF4-FFF2-40B4-BE49-F238E27FC236}">
-                <a16:creationId xmlns:a16="http://schemas.microsoft.com/office/drawing/2014/main" id="{51A6575E-8385-464F-84E8-63161357121F}"/>
+                <a16:creationId xmlns:a16="http://schemas.microsoft.com/office/drawing/2014/main" id="{DD138245-BBF9-452F-A021-B896793D7212}"/>
               </a:ext>
             </a:extLst>
           </p:cNvPr>
@@ -4899,7 +4905,7 @@
           <p:cNvPr id="17" name="">
             <a:extLst xmlns:a="http://schemas.openxmlformats.org/drawingml/2006/main">
               <a:ext uri="{FF2B5EF4-FFF2-40B4-BE49-F238E27FC236}">
-                <a16:creationId xmlns:a16="http://schemas.microsoft.com/office/drawing/2014/main" id="{D01C0B4D-7874-4C08-BC6B-0348B47C92F0}"/>
+                <a16:creationId xmlns:a16="http://schemas.microsoft.com/office/drawing/2014/main" id="{37C06658-4BE6-440A-9D69-16374A0A58B2}"/>
               </a:ext>
             </a:extLst>
           </p:cNvPr>
@@ -4955,7 +4961,7 @@
           <p:cNvPr id="18" name="">
             <a:extLst xmlns:a="http://schemas.openxmlformats.org/drawingml/2006/main">
               <a:ext uri="{FF2B5EF4-FFF2-40B4-BE49-F238E27FC236}">
-                <a16:creationId xmlns:a16="http://schemas.microsoft.com/office/drawing/2014/main" id="{8787561B-7FC2-495A-AADE-BA7227A6D80C}"/>
+                <a16:creationId xmlns:a16="http://schemas.microsoft.com/office/drawing/2014/main" id="{1000491C-5BE9-4DC3-9181-7248510DCCF4}"/>
               </a:ext>
             </a:extLst>
           </p:cNvPr>
@@ -5011,7 +5017,7 @@
           <p:cNvPr id="19" name="">
             <a:extLst xmlns:a="http://schemas.openxmlformats.org/drawingml/2006/main">
               <a:ext uri="{FF2B5EF4-FFF2-40B4-BE49-F238E27FC236}">
-                <a16:creationId xmlns:a16="http://schemas.microsoft.com/office/drawing/2014/main" id="{C6CCF9F8-F03F-4FDA-AD2A-7E4AE1DF5358}"/>
+                <a16:creationId xmlns:a16="http://schemas.microsoft.com/office/drawing/2014/main" id="{221018D8-246F-4E33-A924-6562ECF311F0}"/>
               </a:ext>
             </a:extLst>
           </p:cNvPr>
@@ -5067,7 +5073,7 @@
           <p:cNvPr id="20" name="">
             <a:extLst xmlns:a="http://schemas.openxmlformats.org/drawingml/2006/main">
               <a:ext uri="{FF2B5EF4-FFF2-40B4-BE49-F238E27FC236}">
-                <a16:creationId xmlns:a16="http://schemas.microsoft.com/office/drawing/2014/main" id="{4D59A527-4D27-4157-A78D-45C19999FE5A}"/>
+                <a16:creationId xmlns:a16="http://schemas.microsoft.com/office/drawing/2014/main" id="{2D66BFF8-A612-4498-8FBE-7B56D7B8E74B}"/>
               </a:ext>
             </a:extLst>
           </p:cNvPr>
@@ -5108,7 +5114,7 @@
           <p:cNvPr id="21" name="">
             <a:extLst xmlns:a="http://schemas.openxmlformats.org/drawingml/2006/main">
               <a:ext uri="{FF2B5EF4-FFF2-40B4-BE49-F238E27FC236}">
-                <a16:creationId xmlns:a16="http://schemas.microsoft.com/office/drawing/2014/main" id="{127637AE-F8C5-44A1-BADA-C86BEF63F96B}"/>
+                <a16:creationId xmlns:a16="http://schemas.microsoft.com/office/drawing/2014/main" id="{EFB55FC1-61B7-4C56-A101-59142CE8F8F0}"/>
               </a:ext>
             </a:extLst>
           </p:cNvPr>
@@ -5153,7 +5159,7 @@
           <p:nvPr/>
         </p:nvPicPr>
         <p:blipFill>
-          <a:blip xmlns:r="http://schemas.openxmlformats.org/officeDocument/2006/relationships" xmlns:a="http://schemas.openxmlformats.org/drawingml/2006/main" r:embed="R68ed85e8e41d4472"/>
+          <a:blip xmlns:r="http://schemas.openxmlformats.org/officeDocument/2006/relationships" xmlns:a="http://schemas.openxmlformats.org/drawingml/2006/main" r:embed="Rfe5e822c6e1040e4"/>
           <a:srcRect xmlns:a="http://schemas.openxmlformats.org/drawingml/2006/main" l="15358" t="0" r="15358" b="0"/>
           <a:stretch xmlns:a="http://schemas.openxmlformats.org/drawingml/2006/main">
             <a:fillRect l="0" t="0" r="0" b="0"/>
@@ -5176,7 +5182,7 @@
           <p:cNvPr id="23" name="">
             <a:extLst xmlns:a="http://schemas.openxmlformats.org/drawingml/2006/main">
               <a:ext uri="{FF2B5EF4-FFF2-40B4-BE49-F238E27FC236}">
-                <a16:creationId xmlns:a16="http://schemas.microsoft.com/office/drawing/2014/main" id="{8F6CD38C-75FD-487E-A87B-5306A0B88151}"/>
+                <a16:creationId xmlns:a16="http://schemas.microsoft.com/office/drawing/2014/main" id="{9FD4A72A-CD49-4F9B-AA8F-94C6B361BB21}"/>
               </a:ext>
             </a:extLst>
           </p:cNvPr>
@@ -5211,7 +5217,7 @@
           <p:cNvPr id="24" name="">
             <a:extLst xmlns:a="http://schemas.openxmlformats.org/drawingml/2006/main">
               <a:ext uri="{FF2B5EF4-FFF2-40B4-BE49-F238E27FC236}">
-                <a16:creationId xmlns:a16="http://schemas.microsoft.com/office/drawing/2014/main" id="{BFB244B5-9E6F-41C2-9E09-309BBBE4622E}"/>
+                <a16:creationId xmlns:a16="http://schemas.microsoft.com/office/drawing/2014/main" id="{F6C8005D-D6FC-4CF8-96FC-E4EAD85AF105}"/>
               </a:ext>
             </a:extLst>
           </p:cNvPr>
@@ -5267,7 +5273,7 @@
           <p:cNvPr id="25" name="">
             <a:extLst xmlns:a="http://schemas.openxmlformats.org/drawingml/2006/main">
               <a:ext uri="{FF2B5EF4-FFF2-40B4-BE49-F238E27FC236}">
-                <a16:creationId xmlns:a16="http://schemas.microsoft.com/office/drawing/2014/main" id="{A80B89A1-04F9-4AFE-B321-01955EDBF0A6}"/>
+                <a16:creationId xmlns:a16="http://schemas.microsoft.com/office/drawing/2014/main" id="{A4428A7D-1C62-4CA4-90FB-6F79C9C27CEE}"/>
               </a:ext>
             </a:extLst>
           </p:cNvPr>
@@ -5323,7 +5329,7 @@
           <p:cNvPr id="26" name="">
             <a:extLst xmlns:a="http://schemas.openxmlformats.org/drawingml/2006/main">
               <a:ext uri="{FF2B5EF4-FFF2-40B4-BE49-F238E27FC236}">
-                <a16:creationId xmlns:a16="http://schemas.microsoft.com/office/drawing/2014/main" id="{2A7B818C-FDE0-4563-A5C8-262E8DA67CCB}"/>
+                <a16:creationId xmlns:a16="http://schemas.microsoft.com/office/drawing/2014/main" id="{7849E9A3-5D98-4584-B3D1-593415D1F71E}"/>
               </a:ext>
             </a:extLst>
           </p:cNvPr>
@@ -5379,7 +5385,7 @@
           <p:cNvPr id="27" name="">
             <a:extLst xmlns:a="http://schemas.openxmlformats.org/drawingml/2006/main">
               <a:ext uri="{FF2B5EF4-FFF2-40B4-BE49-F238E27FC236}">
-                <a16:creationId xmlns:a16="http://schemas.microsoft.com/office/drawing/2014/main" id="{AC13BE20-FE7D-4A71-884F-A3DC33EA325A}"/>
+                <a16:creationId xmlns:a16="http://schemas.microsoft.com/office/drawing/2014/main" id="{2A3079BE-903A-4A01-A848-7C0E998CA5E0}"/>
               </a:ext>
             </a:extLst>
           </p:cNvPr>
@@ -5414,7 +5420,7 @@
           <p:cNvPr id="28" name="">
             <a:extLst xmlns:a="http://schemas.openxmlformats.org/drawingml/2006/main">
               <a:ext uri="{FF2B5EF4-FFF2-40B4-BE49-F238E27FC236}">
-                <a16:creationId xmlns:a16="http://schemas.microsoft.com/office/drawing/2014/main" id="{4C7AD678-8E41-4DC7-8CB2-FDC9E2E1FEEE}"/>
+                <a16:creationId xmlns:a16="http://schemas.microsoft.com/office/drawing/2014/main" id="{04ABC8E5-F762-46D2-B2E8-C86D79D0110D}"/>
               </a:ext>
             </a:extLst>
           </p:cNvPr>
@@ -5470,7 +5476,7 @@
           <p:cNvPr id="29" name="">
             <a:extLst xmlns:a="http://schemas.openxmlformats.org/drawingml/2006/main">
               <a:ext uri="{FF2B5EF4-FFF2-40B4-BE49-F238E27FC236}">
-                <a16:creationId xmlns:a16="http://schemas.microsoft.com/office/drawing/2014/main" id="{27490ED2-013B-4D3A-9C31-90710B17C3E4}"/>
+                <a16:creationId xmlns:a16="http://schemas.microsoft.com/office/drawing/2014/main" id="{0587CB05-AA5C-4E26-B946-3F32AE61BF23}"/>
               </a:ext>
             </a:extLst>
           </p:cNvPr>
@@ -5505,7 +5511,7 @@
           <p:cNvPr id="30" name="">
             <a:extLst xmlns:a="http://schemas.openxmlformats.org/drawingml/2006/main">
               <a:ext uri="{FF2B5EF4-FFF2-40B4-BE49-F238E27FC236}">
-                <a16:creationId xmlns:a16="http://schemas.microsoft.com/office/drawing/2014/main" id="{3371971E-6619-4F14-A05F-B8442F17E86A}"/>
+                <a16:creationId xmlns:a16="http://schemas.microsoft.com/office/drawing/2014/main" id="{140A8538-5764-41DD-8FF9-F63B81A53139}"/>
               </a:ext>
             </a:extLst>
           </p:cNvPr>
@@ -5561,7 +5567,7 @@
           <p:cNvPr id="31" name="">
             <a:extLst xmlns:a="http://schemas.openxmlformats.org/drawingml/2006/main">
               <a:ext uri="{FF2B5EF4-FFF2-40B4-BE49-F238E27FC236}">
-                <a16:creationId xmlns:a16="http://schemas.microsoft.com/office/drawing/2014/main" id="{5F4FDABF-C650-486C-84B3-7070D918CE31}"/>
+                <a16:creationId xmlns:a16="http://schemas.microsoft.com/office/drawing/2014/main" id="{C5CA2A61-5ED9-48C9-A51B-571DC49101FC}"/>
               </a:ext>
             </a:extLst>
           </p:cNvPr>
@@ -5596,7 +5602,7 @@
           <p:cNvPr id="32" name="">
             <a:extLst xmlns:a="http://schemas.openxmlformats.org/drawingml/2006/main">
               <a:ext uri="{FF2B5EF4-FFF2-40B4-BE49-F238E27FC236}">
-                <a16:creationId xmlns:a16="http://schemas.microsoft.com/office/drawing/2014/main" id="{80D15272-1520-4507-869E-7C489B2E044B}"/>
+                <a16:creationId xmlns:a16="http://schemas.microsoft.com/office/drawing/2014/main" id="{0D7484CB-8471-4EDF-8DD1-796AC3B643B4}"/>
               </a:ext>
             </a:extLst>
           </p:cNvPr>
@@ -5652,7 +5658,7 @@
           <p:cNvPr id="33" name="">
             <a:extLst xmlns:a="http://schemas.openxmlformats.org/drawingml/2006/main">
               <a:ext uri="{FF2B5EF4-FFF2-40B4-BE49-F238E27FC236}">
-                <a16:creationId xmlns:a16="http://schemas.microsoft.com/office/drawing/2014/main" id="{2DA1F594-0FB4-43E3-AA2F-F0D8B056CC6B}"/>
+                <a16:creationId xmlns:a16="http://schemas.microsoft.com/office/drawing/2014/main" id="{8FC28FEB-44C5-452B-BB23-F2913936B0C6}"/>
               </a:ext>
             </a:extLst>
           </p:cNvPr>
@@ -5687,7 +5693,7 @@
           <p:cNvPr id="34" name="">
             <a:extLst xmlns:a="http://schemas.openxmlformats.org/drawingml/2006/main">
               <a:ext uri="{FF2B5EF4-FFF2-40B4-BE49-F238E27FC236}">
-                <a16:creationId xmlns:a16="http://schemas.microsoft.com/office/drawing/2014/main" id="{837004A6-5F8D-432D-ACC0-E92B0ABDDA04}"/>
+                <a16:creationId xmlns:a16="http://schemas.microsoft.com/office/drawing/2014/main" id="{55D4F923-6320-4BE7-861B-8F881B206062}"/>
               </a:ext>
             </a:extLst>
           </p:cNvPr>
@@ -5741,7 +5747,7 @@
     </p:spTree>
     <p:extLst>
       <p:ext uri="{BB962C8B-B14F-4D97-AF65-F5344CB8AC3E}">
-        <p14:creationId xmlns:p14="http://schemas.microsoft.com/office/powerpoint/2010/main" val="1121806086"/>
+        <p14:creationId xmlns:p14="http://schemas.microsoft.com/office/powerpoint/2010/main" val="719835112"/>
       </p:ext>
     </p:extLst>
   </p:cSld>
@@ -5772,7 +5778,7 @@
           <p:cNvPr id="1" name="">
             <a:extLst xmlns:a="http://schemas.openxmlformats.org/drawingml/2006/main">
               <a:ext uri="{FF2B5EF4-FFF2-40B4-BE49-F238E27FC236}">
-                <a16:creationId xmlns:a16="http://schemas.microsoft.com/office/drawing/2014/main" id="{FD26631A-2968-4003-B61B-08C4E2046398}"/>
+                <a16:creationId xmlns:a16="http://schemas.microsoft.com/office/drawing/2014/main" id="{2C28DB5A-2266-4EFD-8792-4E1648B50D60}"/>
               </a:ext>
             </a:extLst>
           </p:cNvPr>
@@ -5828,7 +5834,7 @@
           <p:cNvPr id="2" name="">
             <a:extLst xmlns:a="http://schemas.openxmlformats.org/drawingml/2006/main">
               <a:ext uri="{FF2B5EF4-FFF2-40B4-BE49-F238E27FC236}">
-                <a16:creationId xmlns:a16="http://schemas.microsoft.com/office/drawing/2014/main" id="{99116115-2581-4CD5-B779-F6F65C565DB3}"/>
+                <a16:creationId xmlns:a16="http://schemas.microsoft.com/office/drawing/2014/main" id="{0BBB5D4B-0724-4D98-BF4F-95C2B0A50C42}"/>
               </a:ext>
             </a:extLst>
           </p:cNvPr>
@@ -5884,7 +5890,7 @@
           <p:cNvPr id="3" name="">
             <a:extLst xmlns:a="http://schemas.openxmlformats.org/drawingml/2006/main">
               <a:ext uri="{FF2B5EF4-FFF2-40B4-BE49-F238E27FC236}">
-                <a16:creationId xmlns:a16="http://schemas.microsoft.com/office/drawing/2014/main" id="{B1A65CA3-32A8-47EC-B075-2AC473AD36BA}"/>
+                <a16:creationId xmlns:a16="http://schemas.microsoft.com/office/drawing/2014/main" id="{F6020D89-D5DE-4087-9BDF-2508CE6721FA}"/>
               </a:ext>
             </a:extLst>
           </p:cNvPr>
@@ -5940,7 +5946,7 @@
           <p:cNvPr id="4" name="">
             <a:extLst xmlns:a="http://schemas.openxmlformats.org/drawingml/2006/main">
               <a:ext uri="{FF2B5EF4-FFF2-40B4-BE49-F238E27FC236}">
-                <a16:creationId xmlns:a16="http://schemas.microsoft.com/office/drawing/2014/main" id="{075D5D10-BB22-4F95-9B49-1CE4D2469A60}"/>
+                <a16:creationId xmlns:a16="http://schemas.microsoft.com/office/drawing/2014/main" id="{DEB9D2CF-CBD6-41BE-89B2-45EB9A4B48AC}"/>
               </a:ext>
             </a:extLst>
           </p:cNvPr>
@@ -5973,7 +5979,7 @@
           <p:cNvPr id="5" name="">
             <a:extLst xmlns:a="http://schemas.openxmlformats.org/drawingml/2006/main">
               <a:ext uri="{FF2B5EF4-FFF2-40B4-BE49-F238E27FC236}">
-                <a16:creationId xmlns:a16="http://schemas.microsoft.com/office/drawing/2014/main" id="{E5EB9CDA-8606-4A00-89CF-F66773783DFF}"/>
+                <a16:creationId xmlns:a16="http://schemas.microsoft.com/office/drawing/2014/main" id="{41306CFC-393D-47DA-82CC-829431118525}"/>
               </a:ext>
             </a:extLst>
           </p:cNvPr>
@@ -6029,7 +6035,7 @@
           <p:cNvPr id="6" name="">
             <a:extLst xmlns:a="http://schemas.openxmlformats.org/drawingml/2006/main">
               <a:ext uri="{FF2B5EF4-FFF2-40B4-BE49-F238E27FC236}">
-                <a16:creationId xmlns:a16="http://schemas.microsoft.com/office/drawing/2014/main" id="{86E93AB9-AD12-4595-96C5-0966CDAEFE34}"/>
+                <a16:creationId xmlns:a16="http://schemas.microsoft.com/office/drawing/2014/main" id="{3953DCE8-72B4-49F3-886E-6439A7706F9F}"/>
               </a:ext>
             </a:extLst>
           </p:cNvPr>
@@ -6074,7 +6080,7 @@
           <p:nvPr/>
         </p:nvPicPr>
         <p:blipFill>
-          <a:blip xmlns:r="http://schemas.openxmlformats.org/officeDocument/2006/relationships" xmlns:a="http://schemas.openxmlformats.org/drawingml/2006/main" r:embed="Rf21b2680822b4a2c"/>
+          <a:blip xmlns:r="http://schemas.openxmlformats.org/officeDocument/2006/relationships" xmlns:a="http://schemas.openxmlformats.org/drawingml/2006/main" r:embed="R10e6e33068a649c6"/>
           <a:srcRect xmlns:a="http://schemas.openxmlformats.org/drawingml/2006/main" l="0" t="2866" r="0" b="2866"/>
           <a:stretch xmlns:a="http://schemas.openxmlformats.org/drawingml/2006/main">
             <a:fillRect l="0" t="0" r="0" b="0"/>
@@ -6097,7 +6103,7 @@
           <p:cNvPr id="8" name="">
             <a:extLst xmlns:a="http://schemas.openxmlformats.org/drawingml/2006/main">
               <a:ext uri="{FF2B5EF4-FFF2-40B4-BE49-F238E27FC236}">
-                <a16:creationId xmlns:a16="http://schemas.microsoft.com/office/drawing/2014/main" id="{CCD3D8B5-FDDF-4726-B743-9621B9832DDD}"/>
+                <a16:creationId xmlns:a16="http://schemas.microsoft.com/office/drawing/2014/main" id="{1CA6417E-A65D-4EFC-BFF0-B5985DDAEAB4}"/>
               </a:ext>
             </a:extLst>
           </p:cNvPr>
@@ -6132,7 +6138,7 @@
           <p:cNvPr id="9" name="">
             <a:extLst xmlns:a="http://schemas.openxmlformats.org/drawingml/2006/main">
               <a:ext uri="{FF2B5EF4-FFF2-40B4-BE49-F238E27FC236}">
-                <a16:creationId xmlns:a16="http://schemas.microsoft.com/office/drawing/2014/main" id="{6775531D-CAD9-42FB-81C3-ABC2AC3AD9D4}"/>
+                <a16:creationId xmlns:a16="http://schemas.microsoft.com/office/drawing/2014/main" id="{11EB067E-AA14-4963-8C40-4EA4D47C98D5}"/>
               </a:ext>
             </a:extLst>
           </p:cNvPr>
@@ -6188,7 +6194,7 @@
           <p:cNvPr id="10" name="">
             <a:extLst xmlns:a="http://schemas.openxmlformats.org/drawingml/2006/main">
               <a:ext uri="{FF2B5EF4-FFF2-40B4-BE49-F238E27FC236}">
-                <a16:creationId xmlns:a16="http://schemas.microsoft.com/office/drawing/2014/main" id="{6F7E597D-CE46-4EC2-8B4F-EBBD3547B30D}"/>
+                <a16:creationId xmlns:a16="http://schemas.microsoft.com/office/drawing/2014/main" id="{42222C99-C773-4D3F-AEBB-27FC6D29AAF2}"/>
               </a:ext>
             </a:extLst>
           </p:cNvPr>
@@ -6233,7 +6239,7 @@
           <p:nvPr/>
         </p:nvPicPr>
         <p:blipFill>
-          <a:blip xmlns:r="http://schemas.openxmlformats.org/officeDocument/2006/relationships" xmlns:a="http://schemas.openxmlformats.org/drawingml/2006/main" r:embed="R4a10246fbd2c46f7"/>
+          <a:blip xmlns:r="http://schemas.openxmlformats.org/officeDocument/2006/relationships" xmlns:a="http://schemas.openxmlformats.org/drawingml/2006/main" r:embed="R93b6b87fe0714510"/>
           <a:srcRect xmlns:a="http://schemas.openxmlformats.org/drawingml/2006/main" l="0" t="18331" r="0" b="18331"/>
           <a:stretch xmlns:a="http://schemas.openxmlformats.org/drawingml/2006/main">
             <a:fillRect l="0" t="0" r="0" b="0"/>
@@ -6256,7 +6262,7 @@
           <p:cNvPr id="12" name="">
             <a:extLst xmlns:a="http://schemas.openxmlformats.org/drawingml/2006/main">
               <a:ext uri="{FF2B5EF4-FFF2-40B4-BE49-F238E27FC236}">
-                <a16:creationId xmlns:a16="http://schemas.microsoft.com/office/drawing/2014/main" id="{A7AA4261-C2BE-45E4-B64D-8C9CE363B48A}"/>
+                <a16:creationId xmlns:a16="http://schemas.microsoft.com/office/drawing/2014/main" id="{F9A2386A-C554-424B-AF03-4C7A5BD1674C}"/>
               </a:ext>
             </a:extLst>
           </p:cNvPr>
@@ -6301,7 +6307,7 @@
           <p:nvPr/>
         </p:nvPicPr>
         <p:blipFill>
-          <a:blip xmlns:r="http://schemas.openxmlformats.org/officeDocument/2006/relationships" xmlns:a="http://schemas.openxmlformats.org/drawingml/2006/main" r:embed="R77d30e8f29e1414f"/>
+          <a:blip xmlns:r="http://schemas.openxmlformats.org/officeDocument/2006/relationships" xmlns:a="http://schemas.openxmlformats.org/drawingml/2006/main" r:embed="R2f9c8e71f12744fd"/>
           <a:srcRect xmlns:a="http://schemas.openxmlformats.org/drawingml/2006/main" l="2102" t="0" r="2102" b="0"/>
           <a:stretch xmlns:a="http://schemas.openxmlformats.org/drawingml/2006/main">
             <a:fillRect l="0" t="0" r="0" b="0"/>
@@ -6324,7 +6330,7 @@
           <p:cNvPr id="14" name="">
             <a:extLst xmlns:a="http://schemas.openxmlformats.org/drawingml/2006/main">
               <a:ext uri="{FF2B5EF4-FFF2-40B4-BE49-F238E27FC236}">
-                <a16:creationId xmlns:a16="http://schemas.microsoft.com/office/drawing/2014/main" id="{BA89BB10-E264-4059-93A2-36731ECC0056}"/>
+                <a16:creationId xmlns:a16="http://schemas.microsoft.com/office/drawing/2014/main" id="{2C66FB59-963F-4844-A9E5-9039352258F9}"/>
               </a:ext>
             </a:extLst>
           </p:cNvPr>
@@ -6365,7 +6371,7 @@
           <p:cNvPr id="15" name="">
             <a:extLst xmlns:a="http://schemas.openxmlformats.org/drawingml/2006/main">
               <a:ext uri="{FF2B5EF4-FFF2-40B4-BE49-F238E27FC236}">
-                <a16:creationId xmlns:a16="http://schemas.microsoft.com/office/drawing/2014/main" id="{A13590FB-8E47-4E1F-8CD0-B211322F2232}"/>
+                <a16:creationId xmlns:a16="http://schemas.microsoft.com/office/drawing/2014/main" id="{80761510-092B-4E0C-B3AA-5D8BB98FD276}"/>
               </a:ext>
             </a:extLst>
           </p:cNvPr>
@@ -6400,7 +6406,7 @@
           <p:cNvPr id="16" name="">
             <a:extLst xmlns:a="http://schemas.openxmlformats.org/drawingml/2006/main">
               <a:ext uri="{FF2B5EF4-FFF2-40B4-BE49-F238E27FC236}">
-                <a16:creationId xmlns:a16="http://schemas.microsoft.com/office/drawing/2014/main" id="{4C8EC6E1-8246-43BC-8E51-E997B86D296C}"/>
+                <a16:creationId xmlns:a16="http://schemas.microsoft.com/office/drawing/2014/main" id="{2CA277C5-396C-4733-9200-1FE2E7B8ACA2}"/>
               </a:ext>
             </a:extLst>
           </p:cNvPr>
@@ -6456,7 +6462,7 @@
           <p:cNvPr id="17" name="">
             <a:extLst xmlns:a="http://schemas.openxmlformats.org/drawingml/2006/main">
               <a:ext uri="{FF2B5EF4-FFF2-40B4-BE49-F238E27FC236}">
-                <a16:creationId xmlns:a16="http://schemas.microsoft.com/office/drawing/2014/main" id="{625B85D9-A803-4C25-A82E-1DDC2DD0F656}"/>
+                <a16:creationId xmlns:a16="http://schemas.microsoft.com/office/drawing/2014/main" id="{7627DB0D-AEA6-42E8-98D7-7BFDB559E18A}"/>
               </a:ext>
             </a:extLst>
           </p:cNvPr>
@@ -6512,7 +6518,7 @@
           <p:cNvPr id="18" name="">
             <a:extLst xmlns:a="http://schemas.openxmlformats.org/drawingml/2006/main">
               <a:ext uri="{FF2B5EF4-FFF2-40B4-BE49-F238E27FC236}">
-                <a16:creationId xmlns:a16="http://schemas.microsoft.com/office/drawing/2014/main" id="{E01C9846-9C50-4944-A38D-6612310D1E1D}"/>
+                <a16:creationId xmlns:a16="http://schemas.microsoft.com/office/drawing/2014/main" id="{2B324B50-357C-43BD-BB64-589D5212838E}"/>
               </a:ext>
             </a:extLst>
           </p:cNvPr>
@@ -6568,7 +6574,7 @@
           <p:cNvPr id="19" name="">
             <a:extLst xmlns:a="http://schemas.openxmlformats.org/drawingml/2006/main">
               <a:ext uri="{FF2B5EF4-FFF2-40B4-BE49-F238E27FC236}">
-                <a16:creationId xmlns:a16="http://schemas.microsoft.com/office/drawing/2014/main" id="{A556483C-15F1-44DD-B29F-67DB61A33FFF}"/>
+                <a16:creationId xmlns:a16="http://schemas.microsoft.com/office/drawing/2014/main" id="{91BFDCE5-632E-4189-96BD-351B63423632}"/>
               </a:ext>
             </a:extLst>
           </p:cNvPr>
@@ -6609,7 +6615,7 @@
           <p:cNvPr id="20" name="">
             <a:extLst xmlns:a="http://schemas.openxmlformats.org/drawingml/2006/main">
               <a:ext uri="{FF2B5EF4-FFF2-40B4-BE49-F238E27FC236}">
-                <a16:creationId xmlns:a16="http://schemas.microsoft.com/office/drawing/2014/main" id="{696504FA-BD72-4F90-859E-24B498B5C47A}"/>
+                <a16:creationId xmlns:a16="http://schemas.microsoft.com/office/drawing/2014/main" id="{12DD5E66-FD32-4456-BA46-739B7A260427}"/>
               </a:ext>
             </a:extLst>
           </p:cNvPr>
@@ -6644,7 +6650,7 @@
           <p:cNvPr id="21" name="">
             <a:extLst xmlns:a="http://schemas.openxmlformats.org/drawingml/2006/main">
               <a:ext uri="{FF2B5EF4-FFF2-40B4-BE49-F238E27FC236}">
-                <a16:creationId xmlns:a16="http://schemas.microsoft.com/office/drawing/2014/main" id="{4D7C52F2-D7A4-4A2A-A57E-B913E2810744}"/>
+                <a16:creationId xmlns:a16="http://schemas.microsoft.com/office/drawing/2014/main" id="{5DB38605-DF39-42BA-8F3E-D1509D112EA1}"/>
               </a:ext>
             </a:extLst>
           </p:cNvPr>
@@ -6700,7 +6706,7 @@
           <p:cNvPr id="22" name="">
             <a:extLst xmlns:a="http://schemas.openxmlformats.org/drawingml/2006/main">
               <a:ext uri="{FF2B5EF4-FFF2-40B4-BE49-F238E27FC236}">
-                <a16:creationId xmlns:a16="http://schemas.microsoft.com/office/drawing/2014/main" id="{CB83E609-A5C7-4EAD-9011-369A1E252B55}"/>
+                <a16:creationId xmlns:a16="http://schemas.microsoft.com/office/drawing/2014/main" id="{509D1C3E-FEBB-47E6-9112-7D7A77C59DE4}"/>
               </a:ext>
             </a:extLst>
           </p:cNvPr>
@@ -6756,7 +6762,7 @@
           <p:cNvPr id="23" name="">
             <a:extLst xmlns:a="http://schemas.openxmlformats.org/drawingml/2006/main">
               <a:ext uri="{FF2B5EF4-FFF2-40B4-BE49-F238E27FC236}">
-                <a16:creationId xmlns:a16="http://schemas.microsoft.com/office/drawing/2014/main" id="{2354E17F-266F-4121-8930-9059254A29C3}"/>
+                <a16:creationId xmlns:a16="http://schemas.microsoft.com/office/drawing/2014/main" id="{916F53CE-D385-4E23-A013-DD3A176E133E}"/>
               </a:ext>
             </a:extLst>
           </p:cNvPr>
@@ -6812,7 +6818,7 @@
           <p:cNvPr id="24" name="">
             <a:extLst xmlns:a="http://schemas.openxmlformats.org/drawingml/2006/main">
               <a:ext uri="{FF2B5EF4-FFF2-40B4-BE49-F238E27FC236}">
-                <a16:creationId xmlns:a16="http://schemas.microsoft.com/office/drawing/2014/main" id="{FBF80BA1-077A-4A4A-8388-58F3F918C738}"/>
+                <a16:creationId xmlns:a16="http://schemas.microsoft.com/office/drawing/2014/main" id="{B466268A-C40B-4E3A-A3B5-4987ACF3FDA5}"/>
               </a:ext>
             </a:extLst>
           </p:cNvPr>
@@ -6853,7 +6859,7 @@
           <p:cNvPr id="25" name="">
             <a:extLst xmlns:a="http://schemas.openxmlformats.org/drawingml/2006/main">
               <a:ext uri="{FF2B5EF4-FFF2-40B4-BE49-F238E27FC236}">
-                <a16:creationId xmlns:a16="http://schemas.microsoft.com/office/drawing/2014/main" id="{6DAE734E-CC28-46D6-B270-CB657B669143}"/>
+                <a16:creationId xmlns:a16="http://schemas.microsoft.com/office/drawing/2014/main" id="{C67CFEA9-89A2-4793-8ABA-80A71C828908}"/>
               </a:ext>
             </a:extLst>
           </p:cNvPr>
@@ -6888,7 +6894,7 @@
           <p:cNvPr id="26" name="">
             <a:extLst xmlns:a="http://schemas.openxmlformats.org/drawingml/2006/main">
               <a:ext uri="{FF2B5EF4-FFF2-40B4-BE49-F238E27FC236}">
-                <a16:creationId xmlns:a16="http://schemas.microsoft.com/office/drawing/2014/main" id="{7D2F5B84-C0D3-448B-9921-A33651D3C025}"/>
+                <a16:creationId xmlns:a16="http://schemas.microsoft.com/office/drawing/2014/main" id="{684AEB9C-80C1-4EB9-B482-CB33B2702891}"/>
               </a:ext>
             </a:extLst>
           </p:cNvPr>
@@ -6944,7 +6950,7 @@
           <p:cNvPr id="27" name="">
             <a:extLst xmlns:a="http://schemas.openxmlformats.org/drawingml/2006/main">
               <a:ext uri="{FF2B5EF4-FFF2-40B4-BE49-F238E27FC236}">
-                <a16:creationId xmlns:a16="http://schemas.microsoft.com/office/drawing/2014/main" id="{664546D9-CEC6-4A96-913E-8C598206FF63}"/>
+                <a16:creationId xmlns:a16="http://schemas.microsoft.com/office/drawing/2014/main" id="{6227A18D-C401-4FA8-8E84-524CAE9F67BB}"/>
               </a:ext>
             </a:extLst>
           </p:cNvPr>
@@ -7000,7 +7006,7 @@
           <p:cNvPr id="28" name="">
             <a:extLst xmlns:a="http://schemas.openxmlformats.org/drawingml/2006/main">
               <a:ext uri="{FF2B5EF4-FFF2-40B4-BE49-F238E27FC236}">
-                <a16:creationId xmlns:a16="http://schemas.microsoft.com/office/drawing/2014/main" id="{ABEC4326-C950-4FD9-ABF1-96949BDC1645}"/>
+                <a16:creationId xmlns:a16="http://schemas.microsoft.com/office/drawing/2014/main" id="{5180A7CA-EB70-4BF4-B5A0-C0BAF3FFDDB8}"/>
               </a:ext>
             </a:extLst>
           </p:cNvPr>
@@ -7056,7 +7062,7 @@
           <p:cNvPr id="29" name="">
             <a:extLst xmlns:a="http://schemas.openxmlformats.org/drawingml/2006/main">
               <a:ext uri="{FF2B5EF4-FFF2-40B4-BE49-F238E27FC236}">
-                <a16:creationId xmlns:a16="http://schemas.microsoft.com/office/drawing/2014/main" id="{3F763CFD-1D32-482C-B56C-16BB69F933DA}"/>
+                <a16:creationId xmlns:a16="http://schemas.microsoft.com/office/drawing/2014/main" id="{FC2DBB69-C0BA-4B34-B737-6921465199F1}"/>
               </a:ext>
             </a:extLst>
           </p:cNvPr>
@@ -7097,7 +7103,7 @@
           <p:cNvPr id="30" name="">
             <a:extLst xmlns:a="http://schemas.openxmlformats.org/drawingml/2006/main">
               <a:ext uri="{FF2B5EF4-FFF2-40B4-BE49-F238E27FC236}">
-                <a16:creationId xmlns:a16="http://schemas.microsoft.com/office/drawing/2014/main" id="{29ABB8E8-FA52-4832-BF3B-44097E762C7E}"/>
+                <a16:creationId xmlns:a16="http://schemas.microsoft.com/office/drawing/2014/main" id="{42DBC3B6-26DF-497E-A8EB-8462D32AB194}"/>
               </a:ext>
             </a:extLst>
           </p:cNvPr>
@@ -7132,7 +7138,7 @@
           <p:cNvPr id="31" name="">
             <a:extLst xmlns:a="http://schemas.openxmlformats.org/drawingml/2006/main">
               <a:ext uri="{FF2B5EF4-FFF2-40B4-BE49-F238E27FC236}">
-                <a16:creationId xmlns:a16="http://schemas.microsoft.com/office/drawing/2014/main" id="{E9D4F79E-3743-4D8A-9FB4-5523F9ED4418}"/>
+                <a16:creationId xmlns:a16="http://schemas.microsoft.com/office/drawing/2014/main" id="{D5DAADE2-762A-4954-B583-634014730375}"/>
               </a:ext>
             </a:extLst>
           </p:cNvPr>
@@ -7188,7 +7194,7 @@
           <p:cNvPr id="32" name="">
             <a:extLst xmlns:a="http://schemas.openxmlformats.org/drawingml/2006/main">
               <a:ext uri="{FF2B5EF4-FFF2-40B4-BE49-F238E27FC236}">
-                <a16:creationId xmlns:a16="http://schemas.microsoft.com/office/drawing/2014/main" id="{E6D439FA-39F6-42D4-82E1-5FCAFE7A081A}"/>
+                <a16:creationId xmlns:a16="http://schemas.microsoft.com/office/drawing/2014/main" id="{0C435926-784F-4D79-9137-A93CA5A283F7}"/>
               </a:ext>
             </a:extLst>
           </p:cNvPr>
@@ -7244,7 +7250,7 @@
           <p:cNvPr id="33" name="">
             <a:extLst xmlns:a="http://schemas.openxmlformats.org/drawingml/2006/main">
               <a:ext uri="{FF2B5EF4-FFF2-40B4-BE49-F238E27FC236}">
-                <a16:creationId xmlns:a16="http://schemas.microsoft.com/office/drawing/2014/main" id="{657F34EC-2F16-4D3B-8E2F-4D6719AF934F}"/>
+                <a16:creationId xmlns:a16="http://schemas.microsoft.com/office/drawing/2014/main" id="{67BED6A8-FAE8-4A70-B4A5-6DF0BB8E4FF3}"/>
               </a:ext>
             </a:extLst>
           </p:cNvPr>
@@ -7300,7 +7306,7 @@
           <p:cNvPr id="34" name="">
             <a:extLst xmlns:a="http://schemas.openxmlformats.org/drawingml/2006/main">
               <a:ext uri="{FF2B5EF4-FFF2-40B4-BE49-F238E27FC236}">
-                <a16:creationId xmlns:a16="http://schemas.microsoft.com/office/drawing/2014/main" id="{BE4078F6-2012-4A38-B4F7-AD97E4322B44}"/>
+                <a16:creationId xmlns:a16="http://schemas.microsoft.com/office/drawing/2014/main" id="{3D8456F6-3B59-4301-968F-2CE8C8677EA3}"/>
               </a:ext>
             </a:extLst>
           </p:cNvPr>
@@ -7335,7 +7341,7 @@
           <p:cNvPr id="35" name="">
             <a:extLst xmlns:a="http://schemas.openxmlformats.org/drawingml/2006/main">
               <a:ext uri="{FF2B5EF4-FFF2-40B4-BE49-F238E27FC236}">
-                <a16:creationId xmlns:a16="http://schemas.microsoft.com/office/drawing/2014/main" id="{4BE23A1E-DCB6-4884-B896-CF3BC9EF2902}"/>
+                <a16:creationId xmlns:a16="http://schemas.microsoft.com/office/drawing/2014/main" id="{21B4B26A-82FA-4081-B905-48AE96EFC274}"/>
               </a:ext>
             </a:extLst>
           </p:cNvPr>
@@ -7389,7 +7395,7 @@
     </p:spTree>
     <p:extLst>
       <p:ext uri="{BB962C8B-B14F-4D97-AF65-F5344CB8AC3E}">
-        <p14:creationId xmlns:p14="http://schemas.microsoft.com/office/powerpoint/2010/main" val="36882650"/>
+        <p14:creationId xmlns:p14="http://schemas.microsoft.com/office/powerpoint/2010/main" val="2007505675"/>
       </p:ext>
     </p:extLst>
   </p:cSld>
@@ -7420,7 +7426,7 @@
           <p:cNvPr id="1" name="">
             <a:extLst xmlns:a="http://schemas.openxmlformats.org/drawingml/2006/main">
               <a:ext uri="{FF2B5EF4-FFF2-40B4-BE49-F238E27FC236}">
-                <a16:creationId xmlns:a16="http://schemas.microsoft.com/office/drawing/2014/main" id="{F406BA59-FF3F-49C3-8CF4-060E93B60BC9}"/>
+                <a16:creationId xmlns:a16="http://schemas.microsoft.com/office/drawing/2014/main" id="{4B1E3667-8B77-4CD6-A166-C4473F05D8F2}"/>
               </a:ext>
             </a:extLst>
           </p:cNvPr>
@@ -7476,7 +7482,7 @@
           <p:cNvPr id="2" name="">
             <a:extLst xmlns:a="http://schemas.openxmlformats.org/drawingml/2006/main">
               <a:ext uri="{FF2B5EF4-FFF2-40B4-BE49-F238E27FC236}">
-                <a16:creationId xmlns:a16="http://schemas.microsoft.com/office/drawing/2014/main" id="{23AEF8B9-26F0-4701-8D1E-C381903381D2}"/>
+                <a16:creationId xmlns:a16="http://schemas.microsoft.com/office/drawing/2014/main" id="{1D663052-F9C4-42D6-8C12-CB9A5F8ED9E9}"/>
               </a:ext>
             </a:extLst>
           </p:cNvPr>
@@ -7532,7 +7538,7 @@
           <p:cNvPr id="3" name="">
             <a:extLst xmlns:a="http://schemas.openxmlformats.org/drawingml/2006/main">
               <a:ext uri="{FF2B5EF4-FFF2-40B4-BE49-F238E27FC236}">
-                <a16:creationId xmlns:a16="http://schemas.microsoft.com/office/drawing/2014/main" id="{0DB6C878-7D0E-4C9A-B45A-101B12E7A3D1}"/>
+                <a16:creationId xmlns:a16="http://schemas.microsoft.com/office/drawing/2014/main" id="{5BE2A4D4-069B-4309-8543-6D1BF6FD0C0F}"/>
               </a:ext>
             </a:extLst>
           </p:cNvPr>
@@ -7588,7 +7594,7 @@
           <p:cNvPr id="4" name="">
             <a:extLst xmlns:a="http://schemas.openxmlformats.org/drawingml/2006/main">
               <a:ext uri="{FF2B5EF4-FFF2-40B4-BE49-F238E27FC236}">
-                <a16:creationId xmlns:a16="http://schemas.microsoft.com/office/drawing/2014/main" id="{D405CFB8-9E9D-4363-9F21-36181EA0CF43}"/>
+                <a16:creationId xmlns:a16="http://schemas.microsoft.com/office/drawing/2014/main" id="{D5322F3C-7685-4A62-AD41-38EBE4E9C712}"/>
               </a:ext>
             </a:extLst>
           </p:cNvPr>
@@ -7621,7 +7627,7 @@
           <p:cNvPr id="5" name="">
             <a:extLst xmlns:a="http://schemas.openxmlformats.org/drawingml/2006/main">
               <a:ext uri="{FF2B5EF4-FFF2-40B4-BE49-F238E27FC236}">
-                <a16:creationId xmlns:a16="http://schemas.microsoft.com/office/drawing/2014/main" id="{65F10250-D1E5-4237-937B-AFE01A514247}"/>
+                <a16:creationId xmlns:a16="http://schemas.microsoft.com/office/drawing/2014/main" id="{FBE14F98-3D3C-4030-9F48-43534015E748}"/>
               </a:ext>
             </a:extLst>
           </p:cNvPr>
@@ -7677,7 +7683,7 @@
           <p:cNvPr id="6" name="">
             <a:extLst xmlns:a="http://schemas.openxmlformats.org/drawingml/2006/main">
               <a:ext uri="{FF2B5EF4-FFF2-40B4-BE49-F238E27FC236}">
-                <a16:creationId xmlns:a16="http://schemas.microsoft.com/office/drawing/2014/main" id="{C8E2114A-9769-4B00-9B1D-4D4E8FDCB2E4}"/>
+                <a16:creationId xmlns:a16="http://schemas.microsoft.com/office/drawing/2014/main" id="{D99C1328-374D-4C99-BD69-974388CE1D31}"/>
               </a:ext>
             </a:extLst>
           </p:cNvPr>
@@ -7718,7 +7724,7 @@
           <p:cNvPr id="7" name="">
             <a:extLst xmlns:a="http://schemas.openxmlformats.org/drawingml/2006/main">
               <a:ext uri="{FF2B5EF4-FFF2-40B4-BE49-F238E27FC236}">
-                <a16:creationId xmlns:a16="http://schemas.microsoft.com/office/drawing/2014/main" id="{16D487F8-5911-4323-9883-D6BD97010651}"/>
+                <a16:creationId xmlns:a16="http://schemas.microsoft.com/office/drawing/2014/main" id="{3E1CC3B5-2DC3-495B-81B8-B3B9D1182047}"/>
               </a:ext>
             </a:extLst>
           </p:cNvPr>
@@ -7763,7 +7769,7 @@
           <p:nvPr/>
         </p:nvPicPr>
         <p:blipFill>
-          <a:blip xmlns:r="http://schemas.openxmlformats.org/officeDocument/2006/relationships" xmlns:a="http://schemas.openxmlformats.org/drawingml/2006/main" r:embed="Rf0e6197db2f7465f"/>
+          <a:blip xmlns:r="http://schemas.openxmlformats.org/officeDocument/2006/relationships" xmlns:a="http://schemas.openxmlformats.org/drawingml/2006/main" r:embed="R00eee3f1ed6040c3"/>
           <a:srcRect xmlns:a="http://schemas.openxmlformats.org/drawingml/2006/main" l="20891" t="0" r="20891" b="0"/>
           <a:stretch xmlns:a="http://schemas.openxmlformats.org/drawingml/2006/main">
             <a:fillRect l="0" t="0" r="0" b="0"/>
@@ -7786,7 +7792,7 @@
           <p:cNvPr id="9" name="">
             <a:extLst xmlns:a="http://schemas.openxmlformats.org/drawingml/2006/main">
               <a:ext uri="{FF2B5EF4-FFF2-40B4-BE49-F238E27FC236}">
-                <a16:creationId xmlns:a16="http://schemas.microsoft.com/office/drawing/2014/main" id="{F353966C-7380-401B-9D49-137F1B890D94}"/>
+                <a16:creationId xmlns:a16="http://schemas.microsoft.com/office/drawing/2014/main" id="{2FB39C09-B5CA-4E39-B23E-5C195F9607C7}"/>
               </a:ext>
             </a:extLst>
           </p:cNvPr>
@@ -7821,7 +7827,7 @@
           <p:cNvPr id="10" name="">
             <a:extLst xmlns:a="http://schemas.openxmlformats.org/drawingml/2006/main">
               <a:ext uri="{FF2B5EF4-FFF2-40B4-BE49-F238E27FC236}">
-                <a16:creationId xmlns:a16="http://schemas.microsoft.com/office/drawing/2014/main" id="{191EF5EC-D814-42FA-9AEB-7BE8BD7996ED}"/>
+                <a16:creationId xmlns:a16="http://schemas.microsoft.com/office/drawing/2014/main" id="{2A4F1452-7B22-48CA-AD1A-7FB4A0A5AEB2}"/>
               </a:ext>
             </a:extLst>
           </p:cNvPr>
@@ -7877,7 +7883,7 @@
           <p:cNvPr id="11" name="">
             <a:extLst xmlns:a="http://schemas.openxmlformats.org/drawingml/2006/main">
               <a:ext uri="{FF2B5EF4-FFF2-40B4-BE49-F238E27FC236}">
-                <a16:creationId xmlns:a16="http://schemas.microsoft.com/office/drawing/2014/main" id="{61149018-C8C9-4F08-B8F7-7BD4DC4D51D4}"/>
+                <a16:creationId xmlns:a16="http://schemas.microsoft.com/office/drawing/2014/main" id="{8878EE8F-84A1-4ABA-A354-3298A2BAEAF4}"/>
               </a:ext>
             </a:extLst>
           </p:cNvPr>
@@ -7933,7 +7939,7 @@
           <p:cNvPr id="12" name="">
             <a:extLst xmlns:a="http://schemas.openxmlformats.org/drawingml/2006/main">
               <a:ext uri="{FF2B5EF4-FFF2-40B4-BE49-F238E27FC236}">
-                <a16:creationId xmlns:a16="http://schemas.microsoft.com/office/drawing/2014/main" id="{EDBF2601-C14D-42A1-BF17-32767DD38286}"/>
+                <a16:creationId xmlns:a16="http://schemas.microsoft.com/office/drawing/2014/main" id="{408A0452-4BF7-497C-A585-9C70F4B9BB25}"/>
               </a:ext>
             </a:extLst>
           </p:cNvPr>
@@ -7989,7 +7995,7 @@
           <p:cNvPr id="13" name="">
             <a:extLst xmlns:a="http://schemas.openxmlformats.org/drawingml/2006/main">
               <a:ext uri="{FF2B5EF4-FFF2-40B4-BE49-F238E27FC236}">
-                <a16:creationId xmlns:a16="http://schemas.microsoft.com/office/drawing/2014/main" id="{CCBEAAE9-8C9E-4B6E-A936-9D8BF9A29A84}"/>
+                <a16:creationId xmlns:a16="http://schemas.microsoft.com/office/drawing/2014/main" id="{0FF22EAD-4C45-4153-B110-BE4BA9224469}"/>
               </a:ext>
             </a:extLst>
           </p:cNvPr>
@@ -8030,7 +8036,7 @@
           <p:cNvPr id="14" name="">
             <a:extLst xmlns:a="http://schemas.openxmlformats.org/drawingml/2006/main">
               <a:ext uri="{FF2B5EF4-FFF2-40B4-BE49-F238E27FC236}">
-                <a16:creationId xmlns:a16="http://schemas.microsoft.com/office/drawing/2014/main" id="{5353C1C7-4EAF-4286-9787-EF76FF98C0AB}"/>
+                <a16:creationId xmlns:a16="http://schemas.microsoft.com/office/drawing/2014/main" id="{B0B10EC7-E86F-492F-9D2D-E26D30010BF5}"/>
               </a:ext>
             </a:extLst>
           </p:cNvPr>
@@ -8075,7 +8081,7 @@
           <p:nvPr/>
         </p:nvPicPr>
         <p:blipFill>
-          <a:blip xmlns:r="http://schemas.openxmlformats.org/officeDocument/2006/relationships" xmlns:a="http://schemas.openxmlformats.org/drawingml/2006/main" r:embed="Rd84466dd7e9d4514"/>
+          <a:blip xmlns:r="http://schemas.openxmlformats.org/officeDocument/2006/relationships" xmlns:a="http://schemas.openxmlformats.org/drawingml/2006/main" r:embed="R1ae7bd85c9b547a3"/>
           <a:srcRect xmlns:a="http://schemas.openxmlformats.org/drawingml/2006/main" l="2947" t="0" r="2947" b="0"/>
           <a:stretch xmlns:a="http://schemas.openxmlformats.org/drawingml/2006/main">
             <a:fillRect l="0" t="0" r="0" b="0"/>
@@ -8098,7 +8104,7 @@
           <p:cNvPr id="16" name="">
             <a:extLst xmlns:a="http://schemas.openxmlformats.org/drawingml/2006/main">
               <a:ext uri="{FF2B5EF4-FFF2-40B4-BE49-F238E27FC236}">
-                <a16:creationId xmlns:a16="http://schemas.microsoft.com/office/drawing/2014/main" id="{D40606B5-AB44-41C3-90ED-A6E94DC64DF8}"/>
+                <a16:creationId xmlns:a16="http://schemas.microsoft.com/office/drawing/2014/main" id="{0F065D19-9665-4C26-ABF4-AE24EBE865B3}"/>
               </a:ext>
             </a:extLst>
           </p:cNvPr>
@@ -8133,7 +8139,7 @@
           <p:cNvPr id="17" name="">
             <a:extLst xmlns:a="http://schemas.openxmlformats.org/drawingml/2006/main">
               <a:ext uri="{FF2B5EF4-FFF2-40B4-BE49-F238E27FC236}">
-                <a16:creationId xmlns:a16="http://schemas.microsoft.com/office/drawing/2014/main" id="{0271007D-DA90-4238-B30C-1C7CD1F11B82}"/>
+                <a16:creationId xmlns:a16="http://schemas.microsoft.com/office/drawing/2014/main" id="{9CDEF62B-996E-4AC1-95A2-1E7E0F166295}"/>
               </a:ext>
             </a:extLst>
           </p:cNvPr>
@@ -8189,7 +8195,7 @@
           <p:cNvPr id="18" name="">
             <a:extLst xmlns:a="http://schemas.openxmlformats.org/drawingml/2006/main">
               <a:ext uri="{FF2B5EF4-FFF2-40B4-BE49-F238E27FC236}">
-                <a16:creationId xmlns:a16="http://schemas.microsoft.com/office/drawing/2014/main" id="{301677E7-3E5F-40C8-9A36-A311E7B7F7A5}"/>
+                <a16:creationId xmlns:a16="http://schemas.microsoft.com/office/drawing/2014/main" id="{E775CEC9-5DE3-41FE-9073-FFE9C9777A4F}"/>
               </a:ext>
             </a:extLst>
           </p:cNvPr>
@@ -8245,7 +8251,7 @@
           <p:cNvPr id="19" name="">
             <a:extLst xmlns:a="http://schemas.openxmlformats.org/drawingml/2006/main">
               <a:ext uri="{FF2B5EF4-FFF2-40B4-BE49-F238E27FC236}">
-                <a16:creationId xmlns:a16="http://schemas.microsoft.com/office/drawing/2014/main" id="{ED6A4C8A-872B-414A-9D22-07BF70F5602D}"/>
+                <a16:creationId xmlns:a16="http://schemas.microsoft.com/office/drawing/2014/main" id="{06510C45-5478-4E13-96AC-3CA30DEF534A}"/>
               </a:ext>
             </a:extLst>
           </p:cNvPr>
@@ -8301,7 +8307,7 @@
           <p:cNvPr id="20" name="">
             <a:extLst xmlns:a="http://schemas.openxmlformats.org/drawingml/2006/main">
               <a:ext uri="{FF2B5EF4-FFF2-40B4-BE49-F238E27FC236}">
-                <a16:creationId xmlns:a16="http://schemas.microsoft.com/office/drawing/2014/main" id="{E8FAFCF1-A150-4B22-9171-0AED3A5FFD09}"/>
+                <a16:creationId xmlns:a16="http://schemas.microsoft.com/office/drawing/2014/main" id="{96894026-EB0B-4795-90C2-FD1FDD998789}"/>
               </a:ext>
             </a:extLst>
           </p:cNvPr>
@@ -8342,7 +8348,7 @@
           <p:cNvPr id="21" name="">
             <a:extLst xmlns:a="http://schemas.openxmlformats.org/drawingml/2006/main">
               <a:ext uri="{FF2B5EF4-FFF2-40B4-BE49-F238E27FC236}">
-                <a16:creationId xmlns:a16="http://schemas.microsoft.com/office/drawing/2014/main" id="{0FE7852A-8A6E-4CE6-815A-66B18893496A}"/>
+                <a16:creationId xmlns:a16="http://schemas.microsoft.com/office/drawing/2014/main" id="{87B5492C-5A89-46AF-A657-5373FE75CBF6}"/>
               </a:ext>
             </a:extLst>
           </p:cNvPr>
@@ -8387,7 +8393,7 @@
           <p:nvPr/>
         </p:nvPicPr>
         <p:blipFill>
-          <a:blip xmlns:r="http://schemas.openxmlformats.org/officeDocument/2006/relationships" xmlns:a="http://schemas.openxmlformats.org/drawingml/2006/main" r:embed="R97e76bb270bb470f"/>
+          <a:blip xmlns:r="http://schemas.openxmlformats.org/officeDocument/2006/relationships" xmlns:a="http://schemas.openxmlformats.org/drawingml/2006/main" r:embed="R4a4a77bd9adc4ef3"/>
           <a:srcRect xmlns:a="http://schemas.openxmlformats.org/drawingml/2006/main" l="2853" t="0" r="2853" b="0"/>
           <a:stretch xmlns:a="http://schemas.openxmlformats.org/drawingml/2006/main">
             <a:fillRect l="0" t="0" r="0" b="0"/>
@@ -8410,7 +8416,7 @@
           <p:cNvPr id="23" name="">
             <a:extLst xmlns:a="http://schemas.openxmlformats.org/drawingml/2006/main">
               <a:ext uri="{FF2B5EF4-FFF2-40B4-BE49-F238E27FC236}">
-                <a16:creationId xmlns:a16="http://schemas.microsoft.com/office/drawing/2014/main" id="{29AB1F20-EFE2-40EB-89C8-4DE4FB9B7589}"/>
+                <a16:creationId xmlns:a16="http://schemas.microsoft.com/office/drawing/2014/main" id="{C48A8A24-C63B-47EF-ACC3-EF1F5AAE74B3}"/>
               </a:ext>
             </a:extLst>
           </p:cNvPr>
@@ -8445,7 +8451,7 @@
           <p:cNvPr id="24" name="">
             <a:extLst xmlns:a="http://schemas.openxmlformats.org/drawingml/2006/main">
               <a:ext uri="{FF2B5EF4-FFF2-40B4-BE49-F238E27FC236}">
-                <a16:creationId xmlns:a16="http://schemas.microsoft.com/office/drawing/2014/main" id="{D351ED8A-AF68-4791-9143-4201669379C4}"/>
+                <a16:creationId xmlns:a16="http://schemas.microsoft.com/office/drawing/2014/main" id="{2CA6A75E-E586-4B88-B1B8-B1C14454304C}"/>
               </a:ext>
             </a:extLst>
           </p:cNvPr>
@@ -8501,7 +8507,7 @@
           <p:cNvPr id="25" name="">
             <a:extLst xmlns:a="http://schemas.openxmlformats.org/drawingml/2006/main">
               <a:ext uri="{FF2B5EF4-FFF2-40B4-BE49-F238E27FC236}">
-                <a16:creationId xmlns:a16="http://schemas.microsoft.com/office/drawing/2014/main" id="{D42E9C60-72AA-4E6A-AAE5-F7A162685DAE}"/>
+                <a16:creationId xmlns:a16="http://schemas.microsoft.com/office/drawing/2014/main" id="{D3F56AB3-0B11-4F4A-87E6-BEC9A3ADE2FF}"/>
               </a:ext>
             </a:extLst>
           </p:cNvPr>
@@ -8557,7 +8563,7 @@
           <p:cNvPr id="26" name="">
             <a:extLst xmlns:a="http://schemas.openxmlformats.org/drawingml/2006/main">
               <a:ext uri="{FF2B5EF4-FFF2-40B4-BE49-F238E27FC236}">
-                <a16:creationId xmlns:a16="http://schemas.microsoft.com/office/drawing/2014/main" id="{9BF134AB-1A31-4F37-B2B6-8D39EB04BD42}"/>
+                <a16:creationId xmlns:a16="http://schemas.microsoft.com/office/drawing/2014/main" id="{EF501852-461C-426D-88D3-2162D3979DE6}"/>
               </a:ext>
             </a:extLst>
           </p:cNvPr>
@@ -8611,7 +8617,7 @@
     </p:spTree>
     <p:extLst>
       <p:ext uri="{BB962C8B-B14F-4D97-AF65-F5344CB8AC3E}">
-        <p14:creationId xmlns:p14="http://schemas.microsoft.com/office/powerpoint/2010/main" val="2046619761"/>
+        <p14:creationId xmlns:p14="http://schemas.microsoft.com/office/powerpoint/2010/main" val="40438718"/>
       </p:ext>
     </p:extLst>
   </p:cSld>
@@ -8642,7 +8648,7 @@
           <p:cNvPr id="1" name="">
             <a:extLst xmlns:a="http://schemas.openxmlformats.org/drawingml/2006/main">
               <a:ext uri="{FF2B5EF4-FFF2-40B4-BE49-F238E27FC236}">
-                <a16:creationId xmlns:a16="http://schemas.microsoft.com/office/drawing/2014/main" id="{46DB5ACE-704C-47AE-ABB2-93CE5C67BAA3}"/>
+                <a16:creationId xmlns:a16="http://schemas.microsoft.com/office/drawing/2014/main" id="{856573B3-977B-4250-8717-BBB3465F09A8}"/>
               </a:ext>
             </a:extLst>
           </p:cNvPr>
@@ -8685,7 +8691,7 @@
           <p:nvPr/>
         </p:nvPicPr>
         <p:blipFill>
-          <a:blip xmlns:r="http://schemas.openxmlformats.org/officeDocument/2006/relationships" xmlns:a="http://schemas.openxmlformats.org/drawingml/2006/main" r:embed="R666ddec44ffb445b"/>
+          <a:blip xmlns:r="http://schemas.openxmlformats.org/officeDocument/2006/relationships" xmlns:a="http://schemas.openxmlformats.org/drawingml/2006/main" r:embed="R7057fcbd679e458b"/>
           <a:srcRect xmlns:a="http://schemas.openxmlformats.org/drawingml/2006/main" l="6283" t="0" r="6283" b="0"/>
           <a:stretch xmlns:a="http://schemas.openxmlformats.org/drawingml/2006/main">
             <a:fillRect l="0" t="0" r="0" b="0"/>
@@ -8706,7 +8712,7 @@
           <p:cNvPr id="3" name="">
             <a:extLst xmlns:a="http://schemas.openxmlformats.org/drawingml/2006/main">
               <a:ext uri="{FF2B5EF4-FFF2-40B4-BE49-F238E27FC236}">
-                <a16:creationId xmlns:a16="http://schemas.microsoft.com/office/drawing/2014/main" id="{C691FE8E-5098-433C-BC40-697149AB4F8F}"/>
+                <a16:creationId xmlns:a16="http://schemas.microsoft.com/office/drawing/2014/main" id="{FEEC7384-DF62-4C37-87B6-799A0AFC2373}"/>
               </a:ext>
             </a:extLst>
           </p:cNvPr>
@@ -8734,7 +8740,7 @@
           <p:cNvPr id="4" name="">
             <a:extLst xmlns:a="http://schemas.openxmlformats.org/drawingml/2006/main">
               <a:ext uri="{FF2B5EF4-FFF2-40B4-BE49-F238E27FC236}">
-                <a16:creationId xmlns:a16="http://schemas.microsoft.com/office/drawing/2014/main" id="{1D4AA059-0C8F-4095-810F-B8AB87F7A066}"/>
+                <a16:creationId xmlns:a16="http://schemas.microsoft.com/office/drawing/2014/main" id="{3642B9FB-19B7-4F12-A21C-FD49D11E94EE}"/>
               </a:ext>
             </a:extLst>
           </p:cNvPr>
@@ -8779,7 +8785,7 @@
           <p:nvPr/>
         </p:nvPicPr>
         <p:blipFill>
-          <a:blip xmlns:r="http://schemas.openxmlformats.org/officeDocument/2006/relationships" xmlns:a="http://schemas.openxmlformats.org/drawingml/2006/main" r:embed="R99aefccb82ea43c0"/>
+          <a:blip xmlns:r="http://schemas.openxmlformats.org/officeDocument/2006/relationships" xmlns:a="http://schemas.openxmlformats.org/drawingml/2006/main" r:embed="Rfb9139b857364b28"/>
           <a:stretch xmlns:a="http://schemas.openxmlformats.org/drawingml/2006/main"/>
         </p:blipFill>
         <p:spPr>
@@ -8799,7 +8805,7 @@
           <p:cNvPr id="6" name="">
             <a:extLst xmlns:a="http://schemas.openxmlformats.org/drawingml/2006/main">
               <a:ext uri="{FF2B5EF4-FFF2-40B4-BE49-F238E27FC236}">
-                <a16:creationId xmlns:a16="http://schemas.microsoft.com/office/drawing/2014/main" id="{2E725F95-71A1-4E95-B2CE-4F8D1799A270}"/>
+                <a16:creationId xmlns:a16="http://schemas.microsoft.com/office/drawing/2014/main" id="{4C347999-F7C8-4628-A2F9-55E0C27D2625}"/>
               </a:ext>
             </a:extLst>
           </p:cNvPr>
@@ -8855,7 +8861,7 @@
           <p:cNvPr id="7" name="">
             <a:extLst xmlns:a="http://schemas.openxmlformats.org/drawingml/2006/main">
               <a:ext uri="{FF2B5EF4-FFF2-40B4-BE49-F238E27FC236}">
-                <a16:creationId xmlns:a16="http://schemas.microsoft.com/office/drawing/2014/main" id="{EFE523A0-60FF-4596-BFC4-398E70E9E72A}"/>
+                <a16:creationId xmlns:a16="http://schemas.microsoft.com/office/drawing/2014/main" id="{D7BCD1D1-6F1E-4C52-8469-D660A6366702}"/>
               </a:ext>
             </a:extLst>
           </p:cNvPr>
@@ -8911,7 +8917,7 @@
           <p:cNvPr id="8" name="">
             <a:extLst xmlns:a="http://schemas.openxmlformats.org/drawingml/2006/main">
               <a:ext uri="{FF2B5EF4-FFF2-40B4-BE49-F238E27FC236}">
-                <a16:creationId xmlns:a16="http://schemas.microsoft.com/office/drawing/2014/main" id="{42246251-ABB7-4ABB-96C7-4C2512AB6730}"/>
+                <a16:creationId xmlns:a16="http://schemas.microsoft.com/office/drawing/2014/main" id="{120B688D-3BDE-4C1C-8C77-EAACDA6D010D}"/>
               </a:ext>
             </a:extLst>
           </p:cNvPr>
@@ -8952,7 +8958,7 @@
           <p:cNvPr id="9" name="">
             <a:extLst xmlns:a="http://schemas.openxmlformats.org/drawingml/2006/main">
               <a:ext uri="{FF2B5EF4-FFF2-40B4-BE49-F238E27FC236}">
-                <a16:creationId xmlns:a16="http://schemas.microsoft.com/office/drawing/2014/main" id="{8E50A4BF-4EBA-4C70-88A6-CDF21F4DD270}"/>
+                <a16:creationId xmlns:a16="http://schemas.microsoft.com/office/drawing/2014/main" id="{8101E2FF-E0FB-4BA8-8356-9958BB1A7375}"/>
               </a:ext>
             </a:extLst>
           </p:cNvPr>
@@ -8985,7 +8991,7 @@
           <p:cNvPr id="10" name="">
             <a:extLst xmlns:a="http://schemas.openxmlformats.org/drawingml/2006/main">
               <a:ext uri="{FF2B5EF4-FFF2-40B4-BE49-F238E27FC236}">
-                <a16:creationId xmlns:a16="http://schemas.microsoft.com/office/drawing/2014/main" id="{548764F7-8607-4EFF-A075-E9A8ECA6AF7B}"/>
+                <a16:creationId xmlns:a16="http://schemas.microsoft.com/office/drawing/2014/main" id="{E55BF9C9-14B7-45B8-84BC-6EF7C5585069}"/>
               </a:ext>
             </a:extLst>
           </p:cNvPr>
@@ -9041,7 +9047,7 @@
           <p:cNvPr id="11" name="">
             <a:extLst xmlns:a="http://schemas.openxmlformats.org/drawingml/2006/main">
               <a:ext uri="{FF2B5EF4-FFF2-40B4-BE49-F238E27FC236}">
-                <a16:creationId xmlns:a16="http://schemas.microsoft.com/office/drawing/2014/main" id="{38C3230A-0079-4C43-A243-6840F8FF0DB0}"/>
+                <a16:creationId xmlns:a16="http://schemas.microsoft.com/office/drawing/2014/main" id="{EE1D01AA-C9BE-407A-97D4-E4C1E018471B}"/>
               </a:ext>
             </a:extLst>
           </p:cNvPr>
@@ -9097,7 +9103,7 @@
           <p:cNvPr id="12" name="">
             <a:extLst xmlns:a="http://schemas.openxmlformats.org/drawingml/2006/main">
               <a:ext uri="{FF2B5EF4-FFF2-40B4-BE49-F238E27FC236}">
-                <a16:creationId xmlns:a16="http://schemas.microsoft.com/office/drawing/2014/main" id="{C90145FA-B755-482C-8F94-1DC72ABEC25C}"/>
+                <a16:creationId xmlns:a16="http://schemas.microsoft.com/office/drawing/2014/main" id="{2798E5B8-5CBE-4B32-8A77-F0857C4126E9}"/>
               </a:ext>
             </a:extLst>
           </p:cNvPr>
@@ -9138,7 +9144,7 @@
           <p:cNvPr id="13" name="">
             <a:extLst xmlns:a="http://schemas.openxmlformats.org/drawingml/2006/main">
               <a:ext uri="{FF2B5EF4-FFF2-40B4-BE49-F238E27FC236}">
-                <a16:creationId xmlns:a16="http://schemas.microsoft.com/office/drawing/2014/main" id="{7DC53E91-D4D2-4E88-A875-4866CC57E05A}"/>
+                <a16:creationId xmlns:a16="http://schemas.microsoft.com/office/drawing/2014/main" id="{22DC217B-0309-49DF-B2C2-C76CD15F4732}"/>
               </a:ext>
             </a:extLst>
           </p:cNvPr>
@@ -9171,7 +9177,7 @@
           <p:cNvPr id="14" name="">
             <a:extLst xmlns:a="http://schemas.openxmlformats.org/drawingml/2006/main">
               <a:ext uri="{FF2B5EF4-FFF2-40B4-BE49-F238E27FC236}">
-                <a16:creationId xmlns:a16="http://schemas.microsoft.com/office/drawing/2014/main" id="{0E300542-5196-4663-A699-97214DFE3333}"/>
+                <a16:creationId xmlns:a16="http://schemas.microsoft.com/office/drawing/2014/main" id="{D0B5BAD1-7374-40E4-818D-0663603E4B0D}"/>
               </a:ext>
             </a:extLst>
           </p:cNvPr>
@@ -9227,7 +9233,7 @@
           <p:cNvPr id="15" name="">
             <a:extLst xmlns:a="http://schemas.openxmlformats.org/drawingml/2006/main">
               <a:ext uri="{FF2B5EF4-FFF2-40B4-BE49-F238E27FC236}">
-                <a16:creationId xmlns:a16="http://schemas.microsoft.com/office/drawing/2014/main" id="{E1EA66E1-520A-429D-BBA3-C87CC98E1BC0}"/>
+                <a16:creationId xmlns:a16="http://schemas.microsoft.com/office/drawing/2014/main" id="{DA8049DB-81F0-4C66-A9C0-78100165F01E}"/>
               </a:ext>
             </a:extLst>
           </p:cNvPr>
@@ -9283,7 +9289,7 @@
           <p:cNvPr id="16" name="">
             <a:extLst xmlns:a="http://schemas.openxmlformats.org/drawingml/2006/main">
               <a:ext uri="{FF2B5EF4-FFF2-40B4-BE49-F238E27FC236}">
-                <a16:creationId xmlns:a16="http://schemas.microsoft.com/office/drawing/2014/main" id="{99EFED72-6F6A-4A7E-B066-C0CCB66A783D}"/>
+                <a16:creationId xmlns:a16="http://schemas.microsoft.com/office/drawing/2014/main" id="{5377C7EF-186E-443E-A7DB-61959C5756C3}"/>
               </a:ext>
             </a:extLst>
           </p:cNvPr>
@@ -9324,7 +9330,7 @@
           <p:cNvPr id="17" name="">
             <a:extLst xmlns:a="http://schemas.openxmlformats.org/drawingml/2006/main">
               <a:ext uri="{FF2B5EF4-FFF2-40B4-BE49-F238E27FC236}">
-                <a16:creationId xmlns:a16="http://schemas.microsoft.com/office/drawing/2014/main" id="{A3E9725E-6CF1-4262-A20F-B96B58CCCC9B}"/>
+                <a16:creationId xmlns:a16="http://schemas.microsoft.com/office/drawing/2014/main" id="{D2B88349-3298-48F1-91E4-28F9B979F14C}"/>
               </a:ext>
             </a:extLst>
           </p:cNvPr>
@@ -9357,7 +9363,7 @@
           <p:cNvPr id="18" name="">
             <a:extLst xmlns:a="http://schemas.openxmlformats.org/drawingml/2006/main">
               <a:ext uri="{FF2B5EF4-FFF2-40B4-BE49-F238E27FC236}">
-                <a16:creationId xmlns:a16="http://schemas.microsoft.com/office/drawing/2014/main" id="{1F9756D2-A0F8-46D8-8618-D3926B285E05}"/>
+                <a16:creationId xmlns:a16="http://schemas.microsoft.com/office/drawing/2014/main" id="{EEB5C763-72D9-4EE2-88EB-D6E76F8789B9}"/>
               </a:ext>
             </a:extLst>
           </p:cNvPr>
@@ -9413,7 +9419,7 @@
           <p:cNvPr id="19" name="">
             <a:extLst xmlns:a="http://schemas.openxmlformats.org/drawingml/2006/main">
               <a:ext uri="{FF2B5EF4-FFF2-40B4-BE49-F238E27FC236}">
-                <a16:creationId xmlns:a16="http://schemas.microsoft.com/office/drawing/2014/main" id="{7916BE7E-39C9-4D77-8438-35C9352F2773}"/>
+                <a16:creationId xmlns:a16="http://schemas.microsoft.com/office/drawing/2014/main" id="{843E9AE1-125C-413E-8C2E-89BF320E572A}"/>
               </a:ext>
             </a:extLst>
           </p:cNvPr>
@@ -9469,7 +9475,7 @@
           <p:cNvPr id="20" name="">
             <a:extLst xmlns:a="http://schemas.openxmlformats.org/drawingml/2006/main">
               <a:ext uri="{FF2B5EF4-FFF2-40B4-BE49-F238E27FC236}">
-                <a16:creationId xmlns:a16="http://schemas.microsoft.com/office/drawing/2014/main" id="{50E8F52D-C97C-4D1F-88EC-1B814FF5403F}"/>
+                <a16:creationId xmlns:a16="http://schemas.microsoft.com/office/drawing/2014/main" id="{CC777486-48CF-4EB9-84D3-44802D79DDB0}"/>
               </a:ext>
             </a:extLst>
           </p:cNvPr>
@@ -9510,7 +9516,7 @@
           <p:cNvPr id="21" name="">
             <a:extLst xmlns:a="http://schemas.openxmlformats.org/drawingml/2006/main">
               <a:ext uri="{FF2B5EF4-FFF2-40B4-BE49-F238E27FC236}">
-                <a16:creationId xmlns:a16="http://schemas.microsoft.com/office/drawing/2014/main" id="{A9E1B0B4-1601-4815-B4A2-B1D86ED8029D}"/>
+                <a16:creationId xmlns:a16="http://schemas.microsoft.com/office/drawing/2014/main" id="{42A74A77-5174-4F09-85D2-AF7C934EF021}"/>
               </a:ext>
             </a:extLst>
           </p:cNvPr>
@@ -9543,7 +9549,7 @@
           <p:cNvPr id="22" name="">
             <a:extLst xmlns:a="http://schemas.openxmlformats.org/drawingml/2006/main">
               <a:ext uri="{FF2B5EF4-FFF2-40B4-BE49-F238E27FC236}">
-                <a16:creationId xmlns:a16="http://schemas.microsoft.com/office/drawing/2014/main" id="{C39E2F01-942F-4DE2-B5DA-1B73FEEFA15E}"/>
+                <a16:creationId xmlns:a16="http://schemas.microsoft.com/office/drawing/2014/main" id="{E25606AE-8CF9-44DE-88D1-613AEED8630A}"/>
               </a:ext>
             </a:extLst>
           </p:cNvPr>
@@ -9599,7 +9605,7 @@
           <p:cNvPr id="23" name="">
             <a:extLst xmlns:a="http://schemas.openxmlformats.org/drawingml/2006/main">
               <a:ext uri="{FF2B5EF4-FFF2-40B4-BE49-F238E27FC236}">
-                <a16:creationId xmlns:a16="http://schemas.microsoft.com/office/drawing/2014/main" id="{951E7E00-ABF4-4041-B8C4-E2C303EBE9C9}"/>
+                <a16:creationId xmlns:a16="http://schemas.microsoft.com/office/drawing/2014/main" id="{E1FA56A8-F8CF-4D5E-92D4-BECEB85B5806}"/>
               </a:ext>
             </a:extLst>
           </p:cNvPr>
@@ -9655,7 +9661,7 @@
           <p:cNvPr id="24" name="">
             <a:extLst xmlns:a="http://schemas.openxmlformats.org/drawingml/2006/main">
               <a:ext uri="{FF2B5EF4-FFF2-40B4-BE49-F238E27FC236}">
-                <a16:creationId xmlns:a16="http://schemas.microsoft.com/office/drawing/2014/main" id="{09560055-B248-4BFB-AC02-6ED374CC2885}"/>
+                <a16:creationId xmlns:a16="http://schemas.microsoft.com/office/drawing/2014/main" id="{7038CBD3-3E30-4DB8-AAD1-D832F0AC7125}"/>
               </a:ext>
             </a:extLst>
           </p:cNvPr>
@@ -9696,7 +9702,7 @@
           <p:cNvPr id="25" name="">
             <a:extLst xmlns:a="http://schemas.openxmlformats.org/drawingml/2006/main">
               <a:ext uri="{FF2B5EF4-FFF2-40B4-BE49-F238E27FC236}">
-                <a16:creationId xmlns:a16="http://schemas.microsoft.com/office/drawing/2014/main" id="{31C31FC6-57CC-4D89-AF3B-E31C4F5CEE2E}"/>
+                <a16:creationId xmlns:a16="http://schemas.microsoft.com/office/drawing/2014/main" id="{F8CE193A-4130-4771-8B73-E899B020AC89}"/>
               </a:ext>
             </a:extLst>
           </p:cNvPr>
@@ -9729,7 +9735,7 @@
           <p:cNvPr id="26" name="">
             <a:extLst xmlns:a="http://schemas.openxmlformats.org/drawingml/2006/main">
               <a:ext uri="{FF2B5EF4-FFF2-40B4-BE49-F238E27FC236}">
-                <a16:creationId xmlns:a16="http://schemas.microsoft.com/office/drawing/2014/main" id="{011523B1-D021-4CC0-95AA-A285D8971851}"/>
+                <a16:creationId xmlns:a16="http://schemas.microsoft.com/office/drawing/2014/main" id="{F3F77E59-9277-4F55-92EF-11D5BC2A720D}"/>
               </a:ext>
             </a:extLst>
           </p:cNvPr>
@@ -9785,7 +9791,7 @@
           <p:cNvPr id="27" name="">
             <a:extLst xmlns:a="http://schemas.openxmlformats.org/drawingml/2006/main">
               <a:ext uri="{FF2B5EF4-FFF2-40B4-BE49-F238E27FC236}">
-                <a16:creationId xmlns:a16="http://schemas.microsoft.com/office/drawing/2014/main" id="{8367A475-A7FE-4361-8075-ACDDF6827C1E}"/>
+                <a16:creationId xmlns:a16="http://schemas.microsoft.com/office/drawing/2014/main" id="{7956BC5D-7090-44F9-B96F-889AFE6AB3D1}"/>
               </a:ext>
             </a:extLst>
           </p:cNvPr>
@@ -9841,7 +9847,7 @@
           <p:cNvPr id="28" name="">
             <a:extLst xmlns:a="http://schemas.openxmlformats.org/drawingml/2006/main">
               <a:ext uri="{FF2B5EF4-FFF2-40B4-BE49-F238E27FC236}">
-                <a16:creationId xmlns:a16="http://schemas.microsoft.com/office/drawing/2014/main" id="{34E6A129-228B-426B-8371-5CBF1E5819CB}"/>
+                <a16:creationId xmlns:a16="http://schemas.microsoft.com/office/drawing/2014/main" id="{613586D3-FD20-4D4D-941B-7A0A9EF6B813}"/>
               </a:ext>
             </a:extLst>
           </p:cNvPr>
@@ -9882,7 +9888,7 @@
           <p:cNvPr id="29" name="">
             <a:extLst xmlns:a="http://schemas.openxmlformats.org/drawingml/2006/main">
               <a:ext uri="{FF2B5EF4-FFF2-40B4-BE49-F238E27FC236}">
-                <a16:creationId xmlns:a16="http://schemas.microsoft.com/office/drawing/2014/main" id="{6CD177BC-74A4-48B4-9C7F-8D6F611C3273}"/>
+                <a16:creationId xmlns:a16="http://schemas.microsoft.com/office/drawing/2014/main" id="{8F32B819-BA99-4950-96F3-FAE652B96429}"/>
               </a:ext>
             </a:extLst>
           </p:cNvPr>
@@ -9915,7 +9921,7 @@
           <p:cNvPr id="30" name="">
             <a:extLst xmlns:a="http://schemas.openxmlformats.org/drawingml/2006/main">
               <a:ext uri="{FF2B5EF4-FFF2-40B4-BE49-F238E27FC236}">
-                <a16:creationId xmlns:a16="http://schemas.microsoft.com/office/drawing/2014/main" id="{734AD667-B098-4496-90E5-8E8AEBCB6AA5}"/>
+                <a16:creationId xmlns:a16="http://schemas.microsoft.com/office/drawing/2014/main" id="{3EC3A4E1-4FD7-47F0-8F98-FBD3E6D55D9F}"/>
               </a:ext>
             </a:extLst>
           </p:cNvPr>
@@ -9971,7 +9977,7 @@
           <p:cNvPr id="31" name="">
             <a:extLst xmlns:a="http://schemas.openxmlformats.org/drawingml/2006/main">
               <a:ext uri="{FF2B5EF4-FFF2-40B4-BE49-F238E27FC236}">
-                <a16:creationId xmlns:a16="http://schemas.microsoft.com/office/drawing/2014/main" id="{EC512A05-85EA-4B2A-AE24-3BCF6587C82C}"/>
+                <a16:creationId xmlns:a16="http://schemas.microsoft.com/office/drawing/2014/main" id="{6AA4B3C9-1B1A-438A-AF20-E3974C6B9044}"/>
               </a:ext>
             </a:extLst>
           </p:cNvPr>
@@ -10027,7 +10033,7 @@
           <p:cNvPr id="32" name="">
             <a:extLst xmlns:a="http://schemas.openxmlformats.org/drawingml/2006/main">
               <a:ext uri="{FF2B5EF4-FFF2-40B4-BE49-F238E27FC236}">
-                <a16:creationId xmlns:a16="http://schemas.microsoft.com/office/drawing/2014/main" id="{3ED11618-A0BE-4F73-A189-AD121BEDEB93}"/>
+                <a16:creationId xmlns:a16="http://schemas.microsoft.com/office/drawing/2014/main" id="{61902072-2649-44D9-B19F-CDC25FF85020}"/>
               </a:ext>
             </a:extLst>
           </p:cNvPr>
@@ -10068,7 +10074,7 @@
           <p:cNvPr id="33" name="">
             <a:extLst xmlns:a="http://schemas.openxmlformats.org/drawingml/2006/main">
               <a:ext uri="{FF2B5EF4-FFF2-40B4-BE49-F238E27FC236}">
-                <a16:creationId xmlns:a16="http://schemas.microsoft.com/office/drawing/2014/main" id="{B401FDE1-9DAF-4249-87EF-4507E4F99FE6}"/>
+                <a16:creationId xmlns:a16="http://schemas.microsoft.com/office/drawing/2014/main" id="{0610B9DE-2E62-45B7-A0BD-117867F2B18B}"/>
               </a:ext>
             </a:extLst>
           </p:cNvPr>
@@ -10101,7 +10107,7 @@
           <p:cNvPr id="34" name="">
             <a:extLst xmlns:a="http://schemas.openxmlformats.org/drawingml/2006/main">
               <a:ext uri="{FF2B5EF4-FFF2-40B4-BE49-F238E27FC236}">
-                <a16:creationId xmlns:a16="http://schemas.microsoft.com/office/drawing/2014/main" id="{500D347A-F943-4F8A-88B3-A7161427741E}"/>
+                <a16:creationId xmlns:a16="http://schemas.microsoft.com/office/drawing/2014/main" id="{11E1D07D-459D-4269-AA63-39CB2EECC693}"/>
               </a:ext>
             </a:extLst>
           </p:cNvPr>
@@ -10157,7 +10163,7 @@
           <p:cNvPr id="35" name="">
             <a:extLst xmlns:a="http://schemas.openxmlformats.org/drawingml/2006/main">
               <a:ext uri="{FF2B5EF4-FFF2-40B4-BE49-F238E27FC236}">
-                <a16:creationId xmlns:a16="http://schemas.microsoft.com/office/drawing/2014/main" id="{C8B38617-7472-44E2-99E5-B6EAFC1FDE31}"/>
+                <a16:creationId xmlns:a16="http://schemas.microsoft.com/office/drawing/2014/main" id="{D7CCDD3D-99BF-4CC2-8A8E-5ACED361E170}"/>
               </a:ext>
             </a:extLst>
           </p:cNvPr>
@@ -10213,7 +10219,7 @@
           <p:cNvPr id="36" name="">
             <a:extLst xmlns:a="http://schemas.openxmlformats.org/drawingml/2006/main">
               <a:ext uri="{FF2B5EF4-FFF2-40B4-BE49-F238E27FC236}">
-                <a16:creationId xmlns:a16="http://schemas.microsoft.com/office/drawing/2014/main" id="{24602AB3-9C16-451C-81EB-BE6B2AE10FBE}"/>
+                <a16:creationId xmlns:a16="http://schemas.microsoft.com/office/drawing/2014/main" id="{A30B8CF2-C3C2-4C40-A5EC-DC1AEF8D2BDD}"/>
               </a:ext>
             </a:extLst>
           </p:cNvPr>
@@ -10254,7 +10260,7 @@
           <p:cNvPr id="37" name="">
             <a:extLst xmlns:a="http://schemas.openxmlformats.org/drawingml/2006/main">
               <a:ext uri="{FF2B5EF4-FFF2-40B4-BE49-F238E27FC236}">
-                <a16:creationId xmlns:a16="http://schemas.microsoft.com/office/drawing/2014/main" id="{9466AADB-B215-498E-A717-743A785EFA1D}"/>
+                <a16:creationId xmlns:a16="http://schemas.microsoft.com/office/drawing/2014/main" id="{6484DA94-AFB6-4560-B364-3B9E4FE5BB3C}"/>
               </a:ext>
             </a:extLst>
           </p:cNvPr>
@@ -10287,7 +10293,7 @@
           <p:cNvPr id="38" name="">
             <a:extLst xmlns:a="http://schemas.openxmlformats.org/drawingml/2006/main">
               <a:ext uri="{FF2B5EF4-FFF2-40B4-BE49-F238E27FC236}">
-                <a16:creationId xmlns:a16="http://schemas.microsoft.com/office/drawing/2014/main" id="{5937ED72-6556-41F1-88AC-ED1DA2385241}"/>
+                <a16:creationId xmlns:a16="http://schemas.microsoft.com/office/drawing/2014/main" id="{472DC4CF-5541-4347-95BC-6D3BE31E31F2}"/>
               </a:ext>
             </a:extLst>
           </p:cNvPr>
@@ -10343,7 +10349,7 @@
           <p:cNvPr id="39" name="">
             <a:extLst xmlns:a="http://schemas.openxmlformats.org/drawingml/2006/main">
               <a:ext uri="{FF2B5EF4-FFF2-40B4-BE49-F238E27FC236}">
-                <a16:creationId xmlns:a16="http://schemas.microsoft.com/office/drawing/2014/main" id="{89364D20-BE8F-440D-BEE4-6B5050F594C8}"/>
+                <a16:creationId xmlns:a16="http://schemas.microsoft.com/office/drawing/2014/main" id="{CEFA289A-F13D-4D22-A163-87C8B6449644}"/>
               </a:ext>
             </a:extLst>
           </p:cNvPr>
@@ -10399,7 +10405,7 @@
           <p:cNvPr id="40" name="">
             <a:extLst xmlns:a="http://schemas.openxmlformats.org/drawingml/2006/main">
               <a:ext uri="{FF2B5EF4-FFF2-40B4-BE49-F238E27FC236}">
-                <a16:creationId xmlns:a16="http://schemas.microsoft.com/office/drawing/2014/main" id="{816A4FAB-13D7-47B3-8F5E-8A943A33B7DC}"/>
+                <a16:creationId xmlns:a16="http://schemas.microsoft.com/office/drawing/2014/main" id="{6D12FCB1-F70C-402A-BF34-F379F1FF7BE3}"/>
               </a:ext>
             </a:extLst>
           </p:cNvPr>
@@ -10440,7 +10446,7 @@
           <p:cNvPr id="41" name="">
             <a:extLst xmlns:a="http://schemas.openxmlformats.org/drawingml/2006/main">
               <a:ext uri="{FF2B5EF4-FFF2-40B4-BE49-F238E27FC236}">
-                <a16:creationId xmlns:a16="http://schemas.microsoft.com/office/drawing/2014/main" id="{D06890BC-6F36-4E63-A01F-F7481744F867}"/>
+                <a16:creationId xmlns:a16="http://schemas.microsoft.com/office/drawing/2014/main" id="{BF09C2B5-5623-4A56-84A1-8B96B2CBEC1F}"/>
               </a:ext>
             </a:extLst>
           </p:cNvPr>
@@ -10473,7 +10479,7 @@
           <p:cNvPr id="42" name="">
             <a:extLst xmlns:a="http://schemas.openxmlformats.org/drawingml/2006/main">
               <a:ext uri="{FF2B5EF4-FFF2-40B4-BE49-F238E27FC236}">
-                <a16:creationId xmlns:a16="http://schemas.microsoft.com/office/drawing/2014/main" id="{44DAE7EA-36C9-473E-AD5E-2B06ABD712BB}"/>
+                <a16:creationId xmlns:a16="http://schemas.microsoft.com/office/drawing/2014/main" id="{F5387B7A-BE67-438E-A2D9-474F8E5B557F}"/>
               </a:ext>
             </a:extLst>
           </p:cNvPr>
@@ -10529,7 +10535,7 @@
           <p:cNvPr id="43" name="">
             <a:extLst xmlns:a="http://schemas.openxmlformats.org/drawingml/2006/main">
               <a:ext uri="{FF2B5EF4-FFF2-40B4-BE49-F238E27FC236}">
-                <a16:creationId xmlns:a16="http://schemas.microsoft.com/office/drawing/2014/main" id="{2E829F79-30AE-45F5-9236-23026257950C}"/>
+                <a16:creationId xmlns:a16="http://schemas.microsoft.com/office/drawing/2014/main" id="{12C6476D-3D97-4B37-A0E9-38E338FC9A98}"/>
               </a:ext>
             </a:extLst>
           </p:cNvPr>
@@ -10585,7 +10591,7 @@
           <p:cNvPr id="44" name="">
             <a:extLst xmlns:a="http://schemas.openxmlformats.org/drawingml/2006/main">
               <a:ext uri="{FF2B5EF4-FFF2-40B4-BE49-F238E27FC236}">
-                <a16:creationId xmlns:a16="http://schemas.microsoft.com/office/drawing/2014/main" id="{F8F117B7-EFF0-4129-AB3C-71AD0331EB48}"/>
+                <a16:creationId xmlns:a16="http://schemas.microsoft.com/office/drawing/2014/main" id="{995627BB-A6E7-4EB7-8108-43C4382FB4DB}"/>
               </a:ext>
             </a:extLst>
           </p:cNvPr>
@@ -10626,7 +10632,7 @@
           <p:cNvPr id="45" name="">
             <a:extLst xmlns:a="http://schemas.openxmlformats.org/drawingml/2006/main">
               <a:ext uri="{FF2B5EF4-FFF2-40B4-BE49-F238E27FC236}">
-                <a16:creationId xmlns:a16="http://schemas.microsoft.com/office/drawing/2014/main" id="{75983C54-AC26-4416-8380-F4763C1CDDC6}"/>
+                <a16:creationId xmlns:a16="http://schemas.microsoft.com/office/drawing/2014/main" id="{4954C8F4-579B-4448-91CF-7222BA5693F6}"/>
               </a:ext>
             </a:extLst>
           </p:cNvPr>
@@ -10705,7 +10711,7 @@
           <p:cNvPr id="46" name="">
             <a:extLst xmlns:a="http://schemas.openxmlformats.org/drawingml/2006/main">
               <a:ext uri="{FF2B5EF4-FFF2-40B4-BE49-F238E27FC236}">
-                <a16:creationId xmlns:a16="http://schemas.microsoft.com/office/drawing/2014/main" id="{302F370D-A5D2-49DF-8354-FB84D8232113}"/>
+                <a16:creationId xmlns:a16="http://schemas.microsoft.com/office/drawing/2014/main" id="{DE19CCDB-9575-41AF-A1A5-D0CD07F0E39C}"/>
               </a:ext>
             </a:extLst>
           </p:cNvPr>
@@ -10761,7 +10767,7 @@
           <p:cNvPr id="47" name="">
             <a:extLst xmlns:a="http://schemas.openxmlformats.org/drawingml/2006/main">
               <a:ext uri="{FF2B5EF4-FFF2-40B4-BE49-F238E27FC236}">
-                <a16:creationId xmlns:a16="http://schemas.microsoft.com/office/drawing/2014/main" id="{6CA30DA7-6742-47A4-A7A2-87FDE3C13167}"/>
+                <a16:creationId xmlns:a16="http://schemas.microsoft.com/office/drawing/2014/main" id="{01688BEE-A743-4347-9F90-56EE4EE31B81}"/>
               </a:ext>
             </a:extLst>
           </p:cNvPr>
@@ -10802,7 +10808,7 @@
           <p:cNvPr id="48" name="">
             <a:extLst xmlns:a="http://schemas.openxmlformats.org/drawingml/2006/main">
               <a:ext uri="{FF2B5EF4-FFF2-40B4-BE49-F238E27FC236}">
-                <a16:creationId xmlns:a16="http://schemas.microsoft.com/office/drawing/2014/main" id="{CE1CCD0A-01AC-4237-A5F5-9CF7993BA408}"/>
+                <a16:creationId xmlns:a16="http://schemas.microsoft.com/office/drawing/2014/main" id="{CB338672-5B2E-4527-8C02-4B82A13AA5CB}"/>
               </a:ext>
             </a:extLst>
           </p:cNvPr>
@@ -10822,7 +10828,7 @@
             </a:avLst>
           </a:prstGeom>
           <a:solidFill xmlns:a="http://schemas.openxmlformats.org/drawingml/2006/main">
-            <a:srgbClr val="102D55"/>
+            <a:srgbClr val="F4F8FF"/>
           </a:solidFill>
           <a:ln xmlns:a="http://schemas.openxmlformats.org/drawingml/2006/main" w="9525">
             <a:solidFill>
@@ -10847,7 +10853,13 @@
           <p:nvPr/>
         </p:nvPicPr>
         <p:blipFill>
-          <a:blip xmlns:r="http://schemas.openxmlformats.org/officeDocument/2006/relationships" xmlns:a="http://schemas.openxmlformats.org/drawingml/2006/main" r:embed="R8710b452433a4439"/>
+          <a:blip xmlns:r="http://schemas.openxmlformats.org/officeDocument/2006/relationships" xmlns:a="http://schemas.openxmlformats.org/drawingml/2006/main" r:embed="R91accb43f5ab4d77">
+            <a:extLst>
+              <a:ext uri="{96DAC541-7B7A-43D3-8B79-37D633B846F1}">
+                <asvg:svgBlip xmlns:asvg="http://schemas.microsoft.com/office/drawing/2016/SVG/main" r:embed="R88e4b1521ad046aa"/>
+              </a:ext>
+            </a:extLst>
+          </a:blip>
           <a:stretch xmlns:a="http://schemas.openxmlformats.org/drawingml/2006/main"/>
         </p:blipFill>
         <p:spPr>
@@ -10867,7 +10879,7 @@
           <p:cNvPr id="50" name="">
             <a:extLst xmlns:a="http://schemas.openxmlformats.org/drawingml/2006/main">
               <a:ext uri="{FF2B5EF4-FFF2-40B4-BE49-F238E27FC236}">
-                <a16:creationId xmlns:a16="http://schemas.microsoft.com/office/drawing/2014/main" id="{6CC4D2E1-8BE3-4352-B748-FB5A40089899}"/>
+                <a16:creationId xmlns:a16="http://schemas.microsoft.com/office/drawing/2014/main" id="{B8BF5E22-1137-4F87-B85B-0E92E8C14A29}"/>
               </a:ext>
             </a:extLst>
           </p:cNvPr>
@@ -10923,7 +10935,7 @@
           <p:cNvPr id="51" name="">
             <a:extLst xmlns:a="http://schemas.openxmlformats.org/drawingml/2006/main">
               <a:ext uri="{FF2B5EF4-FFF2-40B4-BE49-F238E27FC236}">
-                <a16:creationId xmlns:a16="http://schemas.microsoft.com/office/drawing/2014/main" id="{7E2DEE25-86F0-468B-9C4D-B79B9F2DC51C}"/>
+                <a16:creationId xmlns:a16="http://schemas.microsoft.com/office/drawing/2014/main" id="{861DCEDC-51F3-4CE0-8FC4-167E14C630EC}"/>
               </a:ext>
             </a:extLst>
           </p:cNvPr>
@@ -11002,7 +11014,7 @@
           <p:cNvPr id="52" name="">
             <a:extLst xmlns:a="http://schemas.openxmlformats.org/drawingml/2006/main">
               <a:ext uri="{FF2B5EF4-FFF2-40B4-BE49-F238E27FC236}">
-                <a16:creationId xmlns:a16="http://schemas.microsoft.com/office/drawing/2014/main" id="{B408A5DD-D8B0-4318-B57C-4C6D96290141}"/>
+                <a16:creationId xmlns:a16="http://schemas.microsoft.com/office/drawing/2014/main" id="{BC0E1F04-90C9-4DCE-A87D-9AC30BB07DE6}"/>
               </a:ext>
             </a:extLst>
           </p:cNvPr>
@@ -11037,7 +11049,7 @@
           <p:cNvPr id="53" name="">
             <a:extLst xmlns:a="http://schemas.openxmlformats.org/drawingml/2006/main">
               <a:ext uri="{FF2B5EF4-FFF2-40B4-BE49-F238E27FC236}">
-                <a16:creationId xmlns:a16="http://schemas.microsoft.com/office/drawing/2014/main" id="{50D9B13A-A472-4C6C-A228-DEFB38041DF0}"/>
+                <a16:creationId xmlns:a16="http://schemas.microsoft.com/office/drawing/2014/main" id="{FBCE9DC9-E8B1-475B-AB30-5C27719B8DF6}"/>
               </a:ext>
             </a:extLst>
           </p:cNvPr>
@@ -11091,7 +11103,7 @@
     </p:spTree>
     <p:extLst>
       <p:ext uri="{BB962C8B-B14F-4D97-AF65-F5344CB8AC3E}">
-        <p14:creationId xmlns:p14="http://schemas.microsoft.com/office/powerpoint/2010/main" val="586231218"/>
+        <p14:creationId xmlns:p14="http://schemas.microsoft.com/office/powerpoint/2010/main" val="784115894"/>
       </p:ext>
     </p:extLst>
   </p:cSld>

</xml_diff>